<commit_message>
update through lecture 24
</commit_message>
<xml_diff>
--- a/Lecture_Slides/PH 123 Lecture 18.pptx
+++ b/Lecture_Slides/PH 123 Lecture 18.pptx
@@ -5,7 +5,7 @@
     <p:sldMasterId id="2147483648" r:id="rId1"/>
   </p:sldMasterIdLst>
   <p:notesMasterIdLst>
-    <p:notesMasterId r:id="rId46"/>
+    <p:notesMasterId r:id="rId49"/>
   </p:notesMasterIdLst>
   <p:sldIdLst>
     <p:sldId id="293" r:id="rId2"/>
@@ -33,25 +33,28 @@
     <p:sldId id="275" r:id="rId24"/>
     <p:sldId id="286" r:id="rId25"/>
     <p:sldId id="317" r:id="rId26"/>
-    <p:sldId id="318" r:id="rId27"/>
-    <p:sldId id="313" r:id="rId28"/>
-    <p:sldId id="320" r:id="rId29"/>
-    <p:sldId id="314" r:id="rId30"/>
-    <p:sldId id="315" r:id="rId31"/>
-    <p:sldId id="385" r:id="rId32"/>
-    <p:sldId id="294" r:id="rId33"/>
-    <p:sldId id="276" r:id="rId34"/>
-    <p:sldId id="287" r:id="rId35"/>
-    <p:sldId id="288" r:id="rId36"/>
-    <p:sldId id="277" r:id="rId37"/>
-    <p:sldId id="289" r:id="rId38"/>
-    <p:sldId id="278" r:id="rId39"/>
-    <p:sldId id="290" r:id="rId40"/>
-    <p:sldId id="291" r:id="rId41"/>
-    <p:sldId id="292" r:id="rId42"/>
-    <p:sldId id="279" r:id="rId43"/>
-    <p:sldId id="262" r:id="rId44"/>
-    <p:sldId id="263" r:id="rId45"/>
+    <p:sldId id="294" r:id="rId27"/>
+    <p:sldId id="318" r:id="rId28"/>
+    <p:sldId id="313" r:id="rId29"/>
+    <p:sldId id="320" r:id="rId30"/>
+    <p:sldId id="386" r:id="rId31"/>
+    <p:sldId id="314" r:id="rId32"/>
+    <p:sldId id="387" r:id="rId33"/>
+    <p:sldId id="388" r:id="rId34"/>
+    <p:sldId id="385" r:id="rId35"/>
+    <p:sldId id="315" r:id="rId36"/>
+    <p:sldId id="276" r:id="rId37"/>
+    <p:sldId id="287" r:id="rId38"/>
+    <p:sldId id="288" r:id="rId39"/>
+    <p:sldId id="277" r:id="rId40"/>
+    <p:sldId id="289" r:id="rId41"/>
+    <p:sldId id="278" r:id="rId42"/>
+    <p:sldId id="290" r:id="rId43"/>
+    <p:sldId id="291" r:id="rId44"/>
+    <p:sldId id="292" r:id="rId45"/>
+    <p:sldId id="279" r:id="rId46"/>
+    <p:sldId id="262" r:id="rId47"/>
+    <p:sldId id="263" r:id="rId48"/>
   </p:sldIdLst>
   <p:sldSz cx="9144000" cy="6858000" type="screen4x3"/>
   <p:notesSz cx="6858000" cy="9144000"/>
@@ -172,7 +175,7 @@
 <file path=ppt/revisionInfo.xml><?xml version="1.0" encoding="utf-8"?>
 <p1510:revInfo xmlns:a="http://schemas.openxmlformats.org/drawingml/2006/main" xmlns:r="http://schemas.openxmlformats.org/officeDocument/2006/relationships" xmlns:p1510="http://schemas.microsoft.com/office/powerpoint/2015/10/main">
   <p1510:revLst>
-    <p1510:client id="{14A9C7A8-7265-40BC-BF0B-28D359BA5996}" v="29" dt="2026-02-17T19:10:55.230"/>
+    <p1510:client id="{2625DADE-CA5C-4D69-B051-A22A25D7830A}" v="40" dt="2026-05-28T16:39:46.087"/>
   </p1510:revLst>
 </p1510:revInfo>
 </file>
@@ -181,291 +184,240 @@
 <pc:chgInfo xmlns:a="http://schemas.openxmlformats.org/drawingml/2006/main" xmlns:r="http://schemas.openxmlformats.org/officeDocument/2006/relationships" xmlns:ac="http://schemas.microsoft.com/office/drawing/2013/main/command" xmlns:pc="http://schemas.microsoft.com/office/powerpoint/2013/main/command">
   <pc:docChgLst>
     <pc:chgData name="Lines, Todd" userId="afaf7c3a-e8aa-4568-882a-02ad8f9e19b0" providerId="ADAL" clId="{5FF5AC1B-ABA9-43D7-A1E3-2D92732CD6E2}"/>
-    <pc:docChg chg="undo custSel addSld modSld">
-      <pc:chgData name="Lines, Todd" userId="afaf7c3a-e8aa-4568-882a-02ad8f9e19b0" providerId="ADAL" clId="{5FF5AC1B-ABA9-43D7-A1E3-2D92732CD6E2}" dt="2026-02-17T19:11:00.910" v="76" actId="21"/>
+    <pc:docChg chg="undo custSel addSld delSld modSld sldOrd">
+      <pc:chgData name="Lines, Todd" userId="afaf7c3a-e8aa-4568-882a-02ad8f9e19b0" providerId="ADAL" clId="{5FF5AC1B-ABA9-43D7-A1E3-2D92732CD6E2}" dt="2026-05-28T17:26:17.641" v="267"/>
       <pc:docMkLst>
         <pc:docMk/>
       </pc:docMkLst>
+      <pc:sldChg chg="ord">
+        <pc:chgData name="Lines, Todd" userId="afaf7c3a-e8aa-4568-882a-02ad8f9e19b0" providerId="ADAL" clId="{5FF5AC1B-ABA9-43D7-A1E3-2D92732CD6E2}" dt="2026-05-28T17:26:17.641" v="267"/>
+        <pc:sldMkLst>
+          <pc:docMk/>
+          <pc:sldMk cId="2869578996" sldId="294"/>
+        </pc:sldMkLst>
+      </pc:sldChg>
       <pc:sldChg chg="addSp delSp modSp mod">
-        <pc:chgData name="Lines, Todd" userId="afaf7c3a-e8aa-4568-882a-02ad8f9e19b0" providerId="ADAL" clId="{5FF5AC1B-ABA9-43D7-A1E3-2D92732CD6E2}" dt="2026-02-17T19:06:27.974" v="39"/>
+        <pc:chgData name="Lines, Todd" userId="afaf7c3a-e8aa-4568-882a-02ad8f9e19b0" providerId="ADAL" clId="{5FF5AC1B-ABA9-43D7-A1E3-2D92732CD6E2}" dt="2026-05-26T16:08:57.169" v="82" actId="21"/>
+        <pc:sldMkLst>
+          <pc:docMk/>
+          <pc:sldMk cId="784141072" sldId="313"/>
+        </pc:sldMkLst>
+        <pc:picChg chg="add">
+          <ac:chgData name="Lines, Todd" userId="afaf7c3a-e8aa-4568-882a-02ad8f9e19b0" providerId="ADAL" clId="{5FF5AC1B-ABA9-43D7-A1E3-2D92732CD6E2}" dt="2026-05-26T16:08:22.274" v="77" actId="22"/>
+          <ac:picMkLst>
+            <pc:docMk/>
+            <pc:sldMk cId="784141072" sldId="313"/>
+            <ac:picMk id="4" creationId="{8024B42E-0A7C-27DA-0B98-EB93CC4DE964}"/>
+          </ac:picMkLst>
+        </pc:picChg>
+      </pc:sldChg>
+      <pc:sldChg chg="delSp modSp mod ord">
+        <pc:chgData name="Lines, Todd" userId="afaf7c3a-e8aa-4568-882a-02ad8f9e19b0" providerId="ADAL" clId="{5FF5AC1B-ABA9-43D7-A1E3-2D92732CD6E2}" dt="2026-05-28T16:37:02.168" v="260"/>
         <pc:sldMkLst>
           <pc:docMk/>
           <pc:sldMk cId="873789064" sldId="315"/>
         </pc:sldMkLst>
-        <pc:spChg chg="add mod">
-          <ac:chgData name="Lines, Todd" userId="afaf7c3a-e8aa-4568-882a-02ad8f9e19b0" providerId="ADAL" clId="{5FF5AC1B-ABA9-43D7-A1E3-2D92732CD6E2}" dt="2026-02-17T18:33:17.343" v="36" actId="1076"/>
-          <ac:spMkLst>
-            <pc:docMk/>
-            <pc:sldMk cId="873789064" sldId="315"/>
-            <ac:spMk id="4" creationId="{3BCC316E-14B1-061A-5D0E-93BD23D11A6A}"/>
-          </ac:spMkLst>
-        </pc:spChg>
-        <pc:picChg chg="del mod">
-          <ac:chgData name="Lines, Todd" userId="afaf7c3a-e8aa-4568-882a-02ad8f9e19b0" providerId="ADAL" clId="{5FF5AC1B-ABA9-43D7-A1E3-2D92732CD6E2}" dt="2026-02-17T19:00:37.240" v="38" actId="21"/>
+      </pc:sldChg>
+      <pc:sldChg chg="addSp delSp modSp mod">
+        <pc:chgData name="Lines, Todd" userId="afaf7c3a-e8aa-4568-882a-02ad8f9e19b0" providerId="ADAL" clId="{5FF5AC1B-ABA9-43D7-A1E3-2D92732CD6E2}" dt="2026-05-26T16:10:37.524" v="87" actId="1076"/>
+        <pc:sldMkLst>
+          <pc:docMk/>
+          <pc:sldMk cId="2905864846" sldId="320"/>
+        </pc:sldMkLst>
+        <pc:picChg chg="mod">
+          <ac:chgData name="Lines, Todd" userId="afaf7c3a-e8aa-4568-882a-02ad8f9e19b0" providerId="ADAL" clId="{5FF5AC1B-ABA9-43D7-A1E3-2D92732CD6E2}" dt="2026-05-26T16:10:37.524" v="87" actId="1076"/>
           <ac:picMkLst>
             <pc:docMk/>
-            <pc:sldMk cId="873789064" sldId="315"/>
-            <ac:picMk id="12" creationId="{36B847ED-0F67-EA6E-7867-760A4F23BADA}"/>
-          </ac:picMkLst>
-        </pc:picChg>
-        <pc:picChg chg="add mod">
-          <ac:chgData name="Lines, Todd" userId="afaf7c3a-e8aa-4568-882a-02ad8f9e19b0" providerId="ADAL" clId="{5FF5AC1B-ABA9-43D7-A1E3-2D92732CD6E2}" dt="2026-02-17T19:06:27.974" v="39"/>
-          <ac:picMkLst>
-            <pc:docMk/>
-            <pc:sldMk cId="873789064" sldId="315"/>
-            <ac:picMk id="15" creationId="{36B847ED-0F67-EA6E-7867-760A4F23BADA}"/>
+            <pc:sldMk cId="2905864846" sldId="320"/>
+            <ac:picMk id="4" creationId="{00000000-0000-0000-0000-000000000000}"/>
           </ac:picMkLst>
         </pc:picChg>
       </pc:sldChg>
-      <pc:sldChg chg="add">
-        <pc:chgData name="Lines, Todd" userId="afaf7c3a-e8aa-4568-882a-02ad8f9e19b0" providerId="ADAL" clId="{5FF5AC1B-ABA9-43D7-A1E3-2D92732CD6E2}" dt="2026-02-17T17:40:56.776" v="0"/>
-        <pc:sldMkLst>
-          <pc:docMk/>
-          <pc:sldMk cId="2745865935" sldId="373"/>
-        </pc:sldMkLst>
-      </pc:sldChg>
-      <pc:sldChg chg="add">
-        <pc:chgData name="Lines, Todd" userId="afaf7c3a-e8aa-4568-882a-02ad8f9e19b0" providerId="ADAL" clId="{5FF5AC1B-ABA9-43D7-A1E3-2D92732CD6E2}" dt="2026-02-17T17:40:56.776" v="0"/>
-        <pc:sldMkLst>
-          <pc:docMk/>
-          <pc:sldMk cId="4174033270" sldId="374"/>
-        </pc:sldMkLst>
-      </pc:sldChg>
-      <pc:sldChg chg="add">
-        <pc:chgData name="Lines, Todd" userId="afaf7c3a-e8aa-4568-882a-02ad8f9e19b0" providerId="ADAL" clId="{5FF5AC1B-ABA9-43D7-A1E3-2D92732CD6E2}" dt="2026-02-17T17:40:56.776" v="0"/>
-        <pc:sldMkLst>
-          <pc:docMk/>
-          <pc:sldMk cId="1330426859" sldId="375"/>
-        </pc:sldMkLst>
-      </pc:sldChg>
-      <pc:sldChg chg="add">
-        <pc:chgData name="Lines, Todd" userId="afaf7c3a-e8aa-4568-882a-02ad8f9e19b0" providerId="ADAL" clId="{5FF5AC1B-ABA9-43D7-A1E3-2D92732CD6E2}" dt="2026-02-17T17:40:56.776" v="0"/>
-        <pc:sldMkLst>
-          <pc:docMk/>
-          <pc:sldMk cId="3179350182" sldId="376"/>
-        </pc:sldMkLst>
-      </pc:sldChg>
-      <pc:sldChg chg="addSp delSp modSp add mod">
-        <pc:chgData name="Lines, Todd" userId="afaf7c3a-e8aa-4568-882a-02ad8f9e19b0" providerId="ADAL" clId="{5FF5AC1B-ABA9-43D7-A1E3-2D92732CD6E2}" dt="2026-02-17T17:48:07.024" v="34" actId="1076"/>
-        <pc:sldMkLst>
-          <pc:docMk/>
-          <pc:sldMk cId="653680892" sldId="377"/>
-        </pc:sldMkLst>
-        <pc:spChg chg="add del mod">
-          <ac:chgData name="Lines, Todd" userId="afaf7c3a-e8aa-4568-882a-02ad8f9e19b0" providerId="ADAL" clId="{5FF5AC1B-ABA9-43D7-A1E3-2D92732CD6E2}" dt="2026-02-17T17:45:02.048" v="10" actId="478"/>
-          <ac:spMkLst>
-            <pc:docMk/>
-            <pc:sldMk cId="653680892" sldId="377"/>
-            <ac:spMk id="3" creationId="{09E01B28-CB67-A01E-9A48-F18918773E6B}"/>
-          </ac:spMkLst>
-        </pc:spChg>
-        <pc:spChg chg="add mod">
-          <ac:chgData name="Lines, Todd" userId="afaf7c3a-e8aa-4568-882a-02ad8f9e19b0" providerId="ADAL" clId="{5FF5AC1B-ABA9-43D7-A1E3-2D92732CD6E2}" dt="2026-02-17T17:47:16.158" v="27" actId="1035"/>
-          <ac:spMkLst>
-            <pc:docMk/>
-            <pc:sldMk cId="653680892" sldId="377"/>
-            <ac:spMk id="5" creationId="{F2AD214E-C362-4A73-0ADE-08F9C7454802}"/>
-          </ac:spMkLst>
-        </pc:spChg>
-        <pc:spChg chg="add mod">
-          <ac:chgData name="Lines, Todd" userId="afaf7c3a-e8aa-4568-882a-02ad8f9e19b0" providerId="ADAL" clId="{5FF5AC1B-ABA9-43D7-A1E3-2D92732CD6E2}" dt="2026-02-17T17:48:07.024" v="34" actId="1076"/>
-          <ac:spMkLst>
-            <pc:docMk/>
-            <pc:sldMk cId="653680892" sldId="377"/>
-            <ac:spMk id="7" creationId="{09681BFE-C5CE-A222-F010-FEC4215C469B}"/>
-          </ac:spMkLst>
-        </pc:spChg>
-        <pc:spChg chg="del mod">
-          <ac:chgData name="Lines, Todd" userId="afaf7c3a-e8aa-4568-882a-02ad8f9e19b0" providerId="ADAL" clId="{5FF5AC1B-ABA9-43D7-A1E3-2D92732CD6E2}" dt="2026-02-17T17:44:39.199" v="2" actId="478"/>
-          <ac:spMkLst>
-            <pc:docMk/>
-            <pc:sldMk cId="653680892" sldId="377"/>
-            <ac:spMk id="28676" creationId="{00000000-0000-0000-0000-000000000000}"/>
-          </ac:spMkLst>
-        </pc:spChg>
-        <pc:picChg chg="add del mod">
-          <ac:chgData name="Lines, Todd" userId="afaf7c3a-e8aa-4568-882a-02ad8f9e19b0" providerId="ADAL" clId="{5FF5AC1B-ABA9-43D7-A1E3-2D92732CD6E2}" dt="2026-02-17T17:45:13.753" v="14" actId="478"/>
-          <ac:picMkLst>
-            <pc:docMk/>
-            <pc:sldMk cId="653680892" sldId="377"/>
-            <ac:picMk id="1026" creationId="{CBC53A2A-2DEC-F598-50D1-EC464BDE3130}"/>
-          </ac:picMkLst>
-        </pc:picChg>
-        <pc:picChg chg="add mod">
-          <ac:chgData name="Lines, Todd" userId="afaf7c3a-e8aa-4568-882a-02ad8f9e19b0" providerId="ADAL" clId="{5FF5AC1B-ABA9-43D7-A1E3-2D92732CD6E2}" dt="2026-02-17T17:46:40.893" v="21" actId="1076"/>
-          <ac:picMkLst>
-            <pc:docMk/>
-            <pc:sldMk cId="653680892" sldId="377"/>
-            <ac:picMk id="1028" creationId="{F999D2C5-627A-68AF-E3C4-4AB8F44CDB8F}"/>
-          </ac:picMkLst>
-        </pc:picChg>
-        <pc:picChg chg="add mod">
-          <ac:chgData name="Lines, Todd" userId="afaf7c3a-e8aa-4568-882a-02ad8f9e19b0" providerId="ADAL" clId="{5FF5AC1B-ABA9-43D7-A1E3-2D92732CD6E2}" dt="2026-02-17T17:46:44.775" v="22" actId="1076"/>
-          <ac:picMkLst>
-            <pc:docMk/>
-            <pc:sldMk cId="653680892" sldId="377"/>
-            <ac:picMk id="1030" creationId="{3BFB9750-3E64-C873-34D4-51A2A75695E0}"/>
-          </ac:picMkLst>
-        </pc:picChg>
-        <pc:picChg chg="del">
-          <ac:chgData name="Lines, Todd" userId="afaf7c3a-e8aa-4568-882a-02ad8f9e19b0" providerId="ADAL" clId="{5FF5AC1B-ABA9-43D7-A1E3-2D92732CD6E2}" dt="2026-02-17T17:44:56.535" v="7" actId="478"/>
-          <ac:picMkLst>
-            <pc:docMk/>
-            <pc:sldMk cId="653680892" sldId="377"/>
-            <ac:picMk id="28674" creationId="{00000000-0000-0000-0000-000000000000}"/>
-          </ac:picMkLst>
-        </pc:picChg>
-      </pc:sldChg>
-      <pc:sldChg chg="add">
-        <pc:chgData name="Lines, Todd" userId="afaf7c3a-e8aa-4568-882a-02ad8f9e19b0" providerId="ADAL" clId="{5FF5AC1B-ABA9-43D7-A1E3-2D92732CD6E2}" dt="2026-02-17T17:40:56.776" v="0"/>
-        <pc:sldMkLst>
-          <pc:docMk/>
-          <pc:sldMk cId="1780190630" sldId="378"/>
-        </pc:sldMkLst>
-      </pc:sldChg>
-      <pc:sldChg chg="add">
-        <pc:chgData name="Lines, Todd" userId="afaf7c3a-e8aa-4568-882a-02ad8f9e19b0" providerId="ADAL" clId="{5FF5AC1B-ABA9-43D7-A1E3-2D92732CD6E2}" dt="2026-02-17T17:40:56.776" v="0"/>
-        <pc:sldMkLst>
-          <pc:docMk/>
-          <pc:sldMk cId="2112717928" sldId="380"/>
-        </pc:sldMkLst>
-      </pc:sldChg>
-      <pc:sldChg chg="add">
-        <pc:chgData name="Lines, Todd" userId="afaf7c3a-e8aa-4568-882a-02ad8f9e19b0" providerId="ADAL" clId="{5FF5AC1B-ABA9-43D7-A1E3-2D92732CD6E2}" dt="2026-02-17T17:40:56.776" v="0"/>
-        <pc:sldMkLst>
-          <pc:docMk/>
-          <pc:sldMk cId="3249820034" sldId="381"/>
-        </pc:sldMkLst>
-      </pc:sldChg>
-      <pc:sldChg chg="add">
-        <pc:chgData name="Lines, Todd" userId="afaf7c3a-e8aa-4568-882a-02ad8f9e19b0" providerId="ADAL" clId="{5FF5AC1B-ABA9-43D7-A1E3-2D92732CD6E2}" dt="2026-02-17T17:40:56.776" v="0"/>
-        <pc:sldMkLst>
-          <pc:docMk/>
-          <pc:sldMk cId="206940518" sldId="382"/>
-        </pc:sldMkLst>
-      </pc:sldChg>
-      <pc:sldChg chg="add">
-        <pc:chgData name="Lines, Todd" userId="afaf7c3a-e8aa-4568-882a-02ad8f9e19b0" providerId="ADAL" clId="{5FF5AC1B-ABA9-43D7-A1E3-2D92732CD6E2}" dt="2026-02-17T17:40:56.776" v="0"/>
-        <pc:sldMkLst>
-          <pc:docMk/>
-          <pc:sldMk cId="0" sldId="383"/>
-        </pc:sldMkLst>
-      </pc:sldChg>
-      <pc:sldChg chg="add">
-        <pc:chgData name="Lines, Todd" userId="afaf7c3a-e8aa-4568-882a-02ad8f9e19b0" providerId="ADAL" clId="{5FF5AC1B-ABA9-43D7-A1E3-2D92732CD6E2}" dt="2026-02-17T17:40:56.776" v="0"/>
-        <pc:sldMkLst>
-          <pc:docMk/>
-          <pc:sldMk cId="0" sldId="384"/>
-        </pc:sldMkLst>
-      </pc:sldChg>
-      <pc:sldChg chg="addSp delSp modSp add mod">
-        <pc:chgData name="Lines, Todd" userId="afaf7c3a-e8aa-4568-882a-02ad8f9e19b0" providerId="ADAL" clId="{5FF5AC1B-ABA9-43D7-A1E3-2D92732CD6E2}" dt="2026-02-17T19:11:00.910" v="76" actId="21"/>
+      <pc:sldChg chg="addSp delSp modSp mod">
+        <pc:chgData name="Lines, Todd" userId="afaf7c3a-e8aa-4568-882a-02ad8f9e19b0" providerId="ADAL" clId="{5FF5AC1B-ABA9-43D7-A1E3-2D92732CD6E2}" dt="2026-05-28T16:40:15.826" v="265" actId="1076"/>
         <pc:sldMkLst>
           <pc:docMk/>
           <pc:sldMk cId="855844419" sldId="385"/>
         </pc:sldMkLst>
-        <pc:spChg chg="del">
-          <ac:chgData name="Lines, Todd" userId="afaf7c3a-e8aa-4568-882a-02ad8f9e19b0" providerId="ADAL" clId="{5FF5AC1B-ABA9-43D7-A1E3-2D92732CD6E2}" dt="2026-02-17T19:10:44.985" v="74" actId="478"/>
+        <pc:spChg chg="mod">
+          <ac:chgData name="Lines, Todd" userId="afaf7c3a-e8aa-4568-882a-02ad8f9e19b0" providerId="ADAL" clId="{5FF5AC1B-ABA9-43D7-A1E3-2D92732CD6E2}" dt="2026-05-26T22:42:48.212" v="213" actId="20577"/>
           <ac:spMkLst>
             <pc:docMk/>
             <pc:sldMk cId="855844419" sldId="385"/>
-            <ac:spMk id="6" creationId="{C2846985-35DB-E79E-4988-7C48858D41F7}"/>
+            <ac:spMk id="2" creationId="{30465165-FE0C-72FF-F27E-50040A3EEE09}"/>
           </ac:spMkLst>
         </pc:spChg>
-        <pc:spChg chg="del">
-          <ac:chgData name="Lines, Todd" userId="afaf7c3a-e8aa-4568-882a-02ad8f9e19b0" providerId="ADAL" clId="{5FF5AC1B-ABA9-43D7-A1E3-2D92732CD6E2}" dt="2026-02-17T19:10:23.899" v="70" actId="478"/>
+        <pc:spChg chg="mod">
+          <ac:chgData name="Lines, Todd" userId="afaf7c3a-e8aa-4568-882a-02ad8f9e19b0" providerId="ADAL" clId="{5FF5AC1B-ABA9-43D7-A1E3-2D92732CD6E2}" dt="2026-05-26T22:42:53.827" v="214" actId="20577"/>
           <ac:spMkLst>
             <pc:docMk/>
             <pc:sldMk cId="855844419" sldId="385"/>
-            <ac:spMk id="11" creationId="{F79A119A-E9A4-1E5F-4902-935FB519A762}"/>
+            <ac:spMk id="3" creationId="{32AF2C7C-30E9-1176-290E-A5DDED8026FB}"/>
           </ac:spMkLst>
         </pc:spChg>
         <pc:spChg chg="add mod">
-          <ac:chgData name="Lines, Todd" userId="afaf7c3a-e8aa-4568-882a-02ad8f9e19b0" providerId="ADAL" clId="{5FF5AC1B-ABA9-43D7-A1E3-2D92732CD6E2}" dt="2026-02-17T19:06:48.250" v="44" actId="2085"/>
+          <ac:chgData name="Lines, Todd" userId="afaf7c3a-e8aa-4568-882a-02ad8f9e19b0" providerId="ADAL" clId="{5FF5AC1B-ABA9-43D7-A1E3-2D92732CD6E2}" dt="2026-05-27T18:02:02.951" v="226" actId="20577"/>
           <ac:spMkLst>
             <pc:docMk/>
             <pc:sldMk cId="855844419" sldId="385"/>
-            <ac:spMk id="12" creationId="{7A60A404-5F26-A6AB-FA92-97262AE6C916}"/>
+            <ac:spMk id="6" creationId="{78DBAE7E-2531-3CDB-CD71-CDD4992E9972}"/>
           </ac:spMkLst>
         </pc:spChg>
-        <pc:spChg chg="add mod">
-          <ac:chgData name="Lines, Todd" userId="afaf7c3a-e8aa-4568-882a-02ad8f9e19b0" providerId="ADAL" clId="{5FF5AC1B-ABA9-43D7-A1E3-2D92732CD6E2}" dt="2026-02-17T19:08:21.822" v="61" actId="207"/>
+        <pc:spChg chg="mod">
+          <ac:chgData name="Lines, Todd" userId="afaf7c3a-e8aa-4568-882a-02ad8f9e19b0" providerId="ADAL" clId="{5FF5AC1B-ABA9-43D7-A1E3-2D92732CD6E2}" dt="2026-05-26T22:41:46.736" v="212" actId="20577"/>
           <ac:spMkLst>
             <pc:docMk/>
             <pc:sldMk cId="855844419" sldId="385"/>
-            <ac:spMk id="22" creationId="{FF579F81-C611-AF56-9E16-81264727CD9E}"/>
+            <ac:spMk id="7" creationId="{14565300-E9C2-6A20-FE6C-8CD267E127F2}"/>
           </ac:spMkLst>
         </pc:spChg>
-        <pc:spChg chg="add mod">
-          <ac:chgData name="Lines, Todd" userId="afaf7c3a-e8aa-4568-882a-02ad8f9e19b0" providerId="ADAL" clId="{5FF5AC1B-ABA9-43D7-A1E3-2D92732CD6E2}" dt="2026-02-17T19:10:03.798" v="69" actId="1076"/>
-          <ac:spMkLst>
-            <pc:docMk/>
-            <pc:sldMk cId="855844419" sldId="385"/>
-            <ac:spMk id="25" creationId="{2BEE2BAD-9820-2BD8-B7AC-ADC9829791B3}"/>
-          </ac:spMkLst>
-        </pc:spChg>
-        <pc:picChg chg="mod">
-          <ac:chgData name="Lines, Todd" userId="afaf7c3a-e8aa-4568-882a-02ad8f9e19b0" providerId="ADAL" clId="{5FF5AC1B-ABA9-43D7-A1E3-2D92732CD6E2}" dt="2026-02-17T19:10:40.613" v="73" actId="732"/>
+        <pc:picChg chg="add mod modCrop">
+          <ac:chgData name="Lines, Todd" userId="afaf7c3a-e8aa-4568-882a-02ad8f9e19b0" providerId="ADAL" clId="{5FF5AC1B-ABA9-43D7-A1E3-2D92732CD6E2}" dt="2026-05-28T16:40:15.826" v="265" actId="1076"/>
           <ac:picMkLst>
             <pc:docMk/>
             <pc:sldMk cId="855844419" sldId="385"/>
-            <ac:picMk id="5" creationId="{3DB73F6E-2D3E-AFFE-E838-25A499833C66}"/>
+            <ac:picMk id="8" creationId="{3FA4C704-C712-2354-C670-D1048D1F5780}"/>
           </ac:picMkLst>
         </pc:picChg>
         <pc:picChg chg="del mod">
-          <ac:chgData name="Lines, Todd" userId="afaf7c3a-e8aa-4568-882a-02ad8f9e19b0" providerId="ADAL" clId="{5FF5AC1B-ABA9-43D7-A1E3-2D92732CD6E2}" dt="2026-02-17T19:11:00.910" v="76" actId="21"/>
+          <ac:chgData name="Lines, Todd" userId="afaf7c3a-e8aa-4568-882a-02ad8f9e19b0" providerId="ADAL" clId="{5FF5AC1B-ABA9-43D7-A1E3-2D92732CD6E2}" dt="2026-05-27T18:02:22.271" v="228" actId="21"/>
           <ac:picMkLst>
             <pc:docMk/>
             <pc:sldMk cId="855844419" sldId="385"/>
-            <ac:picMk id="27" creationId="{3FDB90C5-9E17-2F00-0514-4866385FFA89}"/>
+            <ac:picMk id="8" creationId="{FB53E62A-8F00-F357-74AF-3207060A8B82}"/>
           </ac:picMkLst>
         </pc:picChg>
-        <pc:cxnChg chg="del">
-          <ac:chgData name="Lines, Todd" userId="afaf7c3a-e8aa-4568-882a-02ad8f9e19b0" providerId="ADAL" clId="{5FF5AC1B-ABA9-43D7-A1E3-2D92732CD6E2}" dt="2026-02-17T19:10:28.578" v="71" actId="478"/>
+      </pc:sldChg>
+      <pc:sldChg chg="addSp delSp modSp new mod">
+        <pc:chgData name="Lines, Todd" userId="afaf7c3a-e8aa-4568-882a-02ad8f9e19b0" providerId="ADAL" clId="{5FF5AC1B-ABA9-43D7-A1E3-2D92732CD6E2}" dt="2026-05-26T22:39:27.263" v="208" actId="21"/>
+        <pc:sldMkLst>
+          <pc:docMk/>
+          <pc:sldMk cId="1379264335" sldId="386"/>
+        </pc:sldMkLst>
+        <pc:picChg chg="add mod">
+          <ac:chgData name="Lines, Todd" userId="afaf7c3a-e8aa-4568-882a-02ad8f9e19b0" providerId="ADAL" clId="{5FF5AC1B-ABA9-43D7-A1E3-2D92732CD6E2}" dt="2026-05-26T22:39:15.205" v="206" actId="1076"/>
+          <ac:picMkLst>
+            <pc:docMk/>
+            <pc:sldMk cId="1379264335" sldId="386"/>
+            <ac:picMk id="20" creationId="{E0466E5D-6BA8-A757-B9F0-CFBBA6BAB41C}"/>
+          </ac:picMkLst>
+        </pc:picChg>
+      </pc:sldChg>
+      <pc:sldChg chg="addSp delSp modSp new mod">
+        <pc:chgData name="Lines, Todd" userId="afaf7c3a-e8aa-4568-882a-02ad8f9e19b0" providerId="ADAL" clId="{5FF5AC1B-ABA9-43D7-A1E3-2D92732CD6E2}" dt="2026-05-26T22:31:29.983" v="199" actId="21"/>
+        <pc:sldMkLst>
+          <pc:docMk/>
+          <pc:sldMk cId="81451399" sldId="387"/>
+        </pc:sldMkLst>
+        <pc:picChg chg="add mod">
+          <ac:chgData name="Lines, Todd" userId="afaf7c3a-e8aa-4568-882a-02ad8f9e19b0" providerId="ADAL" clId="{5FF5AC1B-ABA9-43D7-A1E3-2D92732CD6E2}" dt="2026-05-26T22:31:17.670" v="197" actId="1076"/>
+          <ac:picMkLst>
+            <pc:docMk/>
+            <pc:sldMk cId="81451399" sldId="387"/>
+            <ac:picMk id="17" creationId="{940E75BB-EFFD-69F7-284A-43B9F6136695}"/>
+          </ac:picMkLst>
+        </pc:picChg>
+      </pc:sldChg>
+      <pc:sldChg chg="addSp delSp modSp new mod">
+        <pc:chgData name="Lines, Todd" userId="afaf7c3a-e8aa-4568-882a-02ad8f9e19b0" providerId="ADAL" clId="{5FF5AC1B-ABA9-43D7-A1E3-2D92732CD6E2}" dt="2026-05-28T16:35:40.713" v="258" actId="21"/>
+        <pc:sldMkLst>
+          <pc:docMk/>
+          <pc:sldMk cId="1314439450" sldId="388"/>
+        </pc:sldMkLst>
+        <pc:spChg chg="add mod">
+          <ac:chgData name="Lines, Todd" userId="afaf7c3a-e8aa-4568-882a-02ad8f9e19b0" providerId="ADAL" clId="{5FF5AC1B-ABA9-43D7-A1E3-2D92732CD6E2}" dt="2026-05-28T16:35:13.620" v="248" actId="164"/>
+          <ac:spMkLst>
+            <pc:docMk/>
+            <pc:sldMk cId="1314439450" sldId="388"/>
+            <ac:spMk id="8" creationId="{29370AAA-5077-E913-FEFD-E38F3B8C5DF4}"/>
+          </ac:spMkLst>
+        </pc:spChg>
+        <pc:spChg chg="mod">
+          <ac:chgData name="Lines, Todd" userId="afaf7c3a-e8aa-4568-882a-02ad8f9e19b0" providerId="ADAL" clId="{5FF5AC1B-ABA9-43D7-A1E3-2D92732CD6E2}" dt="2026-05-28T16:35:15.047" v="249"/>
+          <ac:spMkLst>
+            <pc:docMk/>
+            <pc:sldMk cId="1314439450" sldId="388"/>
+            <ac:spMk id="14" creationId="{9B5C2FDC-CE19-4101-06E5-4E873244FDC0}"/>
+          </ac:spMkLst>
+        </pc:spChg>
+        <pc:grpChg chg="add mod">
+          <ac:chgData name="Lines, Todd" userId="afaf7c3a-e8aa-4568-882a-02ad8f9e19b0" providerId="ADAL" clId="{5FF5AC1B-ABA9-43D7-A1E3-2D92732CD6E2}" dt="2026-05-28T16:35:13.620" v="248" actId="164"/>
+          <ac:grpSpMkLst>
+            <pc:docMk/>
+            <pc:sldMk cId="1314439450" sldId="388"/>
+            <ac:grpSpMk id="9" creationId="{E447808C-FB77-A0F5-6182-3F6E360A15F2}"/>
+          </ac:grpSpMkLst>
+        </pc:grpChg>
+        <pc:grpChg chg="add mod">
+          <ac:chgData name="Lines, Todd" userId="afaf7c3a-e8aa-4568-882a-02ad8f9e19b0" providerId="ADAL" clId="{5FF5AC1B-ABA9-43D7-A1E3-2D92732CD6E2}" dt="2026-05-28T16:35:25.886" v="256" actId="1037"/>
+          <ac:grpSpMkLst>
+            <pc:docMk/>
+            <pc:sldMk cId="1314439450" sldId="388"/>
+            <ac:grpSpMk id="10" creationId="{62D75928-C2AA-A496-70B2-8DA1D6E9233B}"/>
+          </ac:grpSpMkLst>
+        </pc:grpChg>
+        <pc:picChg chg="del mod">
+          <ac:chgData name="Lines, Todd" userId="afaf7c3a-e8aa-4568-882a-02ad8f9e19b0" providerId="ADAL" clId="{5FF5AC1B-ABA9-43D7-A1E3-2D92732CD6E2}" dt="2026-05-28T16:35:40.713" v="258" actId="21"/>
+          <ac:picMkLst>
+            <pc:docMk/>
+            <pc:sldMk cId="1314439450" sldId="388"/>
+            <ac:picMk id="15" creationId="{9629B4E6-74F6-65DB-3D00-30F79A51C2F1}"/>
+          </ac:picMkLst>
+        </pc:picChg>
+        <pc:picChg chg="add">
+          <ac:chgData name="Lines, Todd" userId="afaf7c3a-e8aa-4568-882a-02ad8f9e19b0" providerId="ADAL" clId="{5FF5AC1B-ABA9-43D7-A1E3-2D92732CD6E2}" dt="2026-05-26T22:28:19.395" v="188" actId="22"/>
+          <ac:picMkLst>
+            <pc:docMk/>
+            <pc:sldMk cId="1314439450" sldId="388"/>
+            <ac:picMk id="17" creationId="{8CE27FC2-0AA0-9EE0-BCF1-9E04B0185F2C}"/>
+          </ac:picMkLst>
+        </pc:picChg>
+        <pc:cxnChg chg="add mod">
+          <ac:chgData name="Lines, Todd" userId="afaf7c3a-e8aa-4568-882a-02ad8f9e19b0" providerId="ADAL" clId="{5FF5AC1B-ABA9-43D7-A1E3-2D92732CD6E2}" dt="2026-05-28T16:35:13.620" v="248" actId="164"/>
           <ac:cxnSpMkLst>
             <pc:docMk/>
-            <pc:sldMk cId="855844419" sldId="385"/>
-            <ac:cxnSpMk id="8" creationId="{960CBCFF-C368-B04E-501C-F96B403AE5C0}"/>
-          </ac:cxnSpMkLst>
-        </pc:cxnChg>
-        <pc:cxnChg chg="mod ord">
-          <ac:chgData name="Lines, Todd" userId="afaf7c3a-e8aa-4568-882a-02ad8f9e19b0" providerId="ADAL" clId="{5FF5AC1B-ABA9-43D7-A1E3-2D92732CD6E2}" dt="2026-02-17T19:10:32.834" v="72" actId="14100"/>
-          <ac:cxnSpMkLst>
-            <pc:docMk/>
-            <pc:sldMk cId="855844419" sldId="385"/>
-            <ac:cxnSpMk id="10" creationId="{F844211F-6B62-2DF3-155B-F8B55F40E33A}"/>
-          </ac:cxnSpMkLst>
-        </pc:cxnChg>
-        <pc:cxnChg chg="del">
-          <ac:chgData name="Lines, Todd" userId="afaf7c3a-e8aa-4568-882a-02ad8f9e19b0" providerId="ADAL" clId="{5FF5AC1B-ABA9-43D7-A1E3-2D92732CD6E2}" dt="2026-02-17T19:10:23.899" v="70" actId="478"/>
-          <ac:cxnSpMkLst>
-            <pc:docMk/>
-            <pc:sldMk cId="855844419" sldId="385"/>
-            <ac:cxnSpMk id="13" creationId="{DAE52538-65FB-5A4C-6AD7-415DFFAC1650}"/>
+            <pc:sldMk cId="1314439450" sldId="388"/>
+            <ac:cxnSpMk id="3" creationId="{30C16A0F-E1E8-33C4-A992-D3D9B94FCA4F}"/>
           </ac:cxnSpMkLst>
         </pc:cxnChg>
         <pc:cxnChg chg="add mod">
-          <ac:chgData name="Lines, Todd" userId="afaf7c3a-e8aa-4568-882a-02ad8f9e19b0" providerId="ADAL" clId="{5FF5AC1B-ABA9-43D7-A1E3-2D92732CD6E2}" dt="2026-02-17T19:07:30.189" v="52" actId="14100"/>
+          <ac:chgData name="Lines, Todd" userId="afaf7c3a-e8aa-4568-882a-02ad8f9e19b0" providerId="ADAL" clId="{5FF5AC1B-ABA9-43D7-A1E3-2D92732CD6E2}" dt="2026-05-28T16:35:13.620" v="248" actId="164"/>
           <ac:cxnSpMkLst>
             <pc:docMk/>
-            <pc:sldMk cId="855844419" sldId="385"/>
-            <ac:cxnSpMk id="16" creationId="{AF4B9E8A-D3D0-393B-0F3B-42C9C3E877D8}"/>
+            <pc:sldMk cId="1314439450" sldId="388"/>
+            <ac:cxnSpMk id="4" creationId="{745CADA5-E28F-06EE-5B64-45FA731C7E72}"/>
           </ac:cxnSpMkLst>
         </pc:cxnChg>
         <pc:cxnChg chg="add mod">
-          <ac:chgData name="Lines, Todd" userId="afaf7c3a-e8aa-4568-882a-02ad8f9e19b0" providerId="ADAL" clId="{5FF5AC1B-ABA9-43D7-A1E3-2D92732CD6E2}" dt="2026-02-17T19:08:06.681" v="57" actId="1582"/>
+          <ac:chgData name="Lines, Todd" userId="afaf7c3a-e8aa-4568-882a-02ad8f9e19b0" providerId="ADAL" clId="{5FF5AC1B-ABA9-43D7-A1E3-2D92732CD6E2}" dt="2026-05-28T16:35:13.620" v="248" actId="164"/>
           <ac:cxnSpMkLst>
             <pc:docMk/>
-            <pc:sldMk cId="855844419" sldId="385"/>
-            <ac:cxnSpMk id="21" creationId="{70E7C15F-4CD4-9C43-BD1D-D907E35AD5D9}"/>
+            <pc:sldMk cId="1314439450" sldId="388"/>
+            <ac:cxnSpMk id="6" creationId="{34007F80-DF72-CE6F-D5EC-E7C477A521A8}"/>
           </ac:cxnSpMkLst>
         </pc:cxnChg>
-        <pc:cxnChg chg="add mod">
-          <ac:chgData name="Lines, Todd" userId="afaf7c3a-e8aa-4568-882a-02ad8f9e19b0" providerId="ADAL" clId="{5FF5AC1B-ABA9-43D7-A1E3-2D92732CD6E2}" dt="2026-02-17T19:08:41.501" v="66" actId="1582"/>
+        <pc:cxnChg chg="mod">
+          <ac:chgData name="Lines, Todd" userId="afaf7c3a-e8aa-4568-882a-02ad8f9e19b0" providerId="ADAL" clId="{5FF5AC1B-ABA9-43D7-A1E3-2D92732CD6E2}" dt="2026-05-28T16:35:15.047" v="249"/>
           <ac:cxnSpMkLst>
             <pc:docMk/>
-            <pc:sldMk cId="855844419" sldId="385"/>
-            <ac:cxnSpMk id="23" creationId="{3E42D5FE-1662-1927-3CF2-EC86929AF629}"/>
+            <pc:sldMk cId="1314439450" sldId="388"/>
+            <ac:cxnSpMk id="11" creationId="{C8056505-7A0A-4AD6-CF72-D15F6DE0ACC1}"/>
+          </ac:cxnSpMkLst>
+        </pc:cxnChg>
+        <pc:cxnChg chg="mod">
+          <ac:chgData name="Lines, Todd" userId="afaf7c3a-e8aa-4568-882a-02ad8f9e19b0" providerId="ADAL" clId="{5FF5AC1B-ABA9-43D7-A1E3-2D92732CD6E2}" dt="2026-05-28T16:35:15.047" v="249"/>
+          <ac:cxnSpMkLst>
+            <pc:docMk/>
+            <pc:sldMk cId="1314439450" sldId="388"/>
+            <ac:cxnSpMk id="12" creationId="{E909BCC5-ED11-0400-14EF-21C327334430}"/>
+          </ac:cxnSpMkLst>
+        </pc:cxnChg>
+        <pc:cxnChg chg="mod">
+          <ac:chgData name="Lines, Todd" userId="afaf7c3a-e8aa-4568-882a-02ad8f9e19b0" providerId="ADAL" clId="{5FF5AC1B-ABA9-43D7-A1E3-2D92732CD6E2}" dt="2026-05-28T16:35:15.047" v="249"/>
+          <ac:cxnSpMkLst>
+            <pc:docMk/>
+            <pc:sldMk cId="1314439450" sldId="388"/>
+            <ac:cxnSpMk id="13" creationId="{E623E685-7FCD-8BAC-2334-9C02D2EB3EAE}"/>
           </ac:cxnSpMkLst>
         </pc:cxnChg>
       </pc:sldChg>
@@ -556,7 +508,7 @@
           <a:p>
             <a:fld id="{8B442B61-E92B-448B-901B-F4BC73FBCE5B}" type="datetimeFigureOut">
               <a:rPr lang="en-US" smtClean="0"/>
-              <a:t>2/17/2026</a:t>
+              <a:t>5/28/2026</a:t>
             </a:fld>
             <a:endParaRPr lang="en-US"/>
           </a:p>
@@ -1029,90 +981,6 @@
   <p:cSld>
     <p:spTree>
       <p:nvGrpSpPr>
-        <p:cNvPr id="1" name=""/>
-        <p:cNvGrpSpPr/>
-        <p:nvPr/>
-      </p:nvGrpSpPr>
-      <p:grpSpPr>
-        <a:xfrm>
-          <a:off x="0" y="0"/>
-          <a:ext cx="0" cy="0"/>
-          <a:chOff x="0" y="0"/>
-          <a:chExt cx="0" cy="0"/>
-        </a:xfrm>
-      </p:grpSpPr>
-      <p:sp>
-        <p:nvSpPr>
-          <p:cNvPr id="2" name="Slide Image Placeholder 1"/>
-          <p:cNvSpPr>
-            <a:spLocks noGrp="1" noRot="1" noChangeAspect="1"/>
-          </p:cNvSpPr>
-          <p:nvPr>
-            <p:ph type="sldImg"/>
-          </p:nvPr>
-        </p:nvSpPr>
-        <p:spPr/>
-      </p:sp>
-      <p:sp>
-        <p:nvSpPr>
-          <p:cNvPr id="3" name="Notes Placeholder 2"/>
-          <p:cNvSpPr>
-            <a:spLocks noGrp="1"/>
-          </p:cNvSpPr>
-          <p:nvPr>
-            <p:ph type="body" idx="1"/>
-          </p:nvPr>
-        </p:nvSpPr>
-        <p:spPr/>
-        <p:txBody>
-          <a:bodyPr/>
-          <a:lstStyle/>
-          <a:p>
-            <a:endParaRPr lang="en-US" dirty="0"/>
-          </a:p>
-        </p:txBody>
-      </p:sp>
-      <p:sp>
-        <p:nvSpPr>
-          <p:cNvPr id="4" name="Slide Number Placeholder 3"/>
-          <p:cNvSpPr>
-            <a:spLocks noGrp="1"/>
-          </p:cNvSpPr>
-          <p:nvPr>
-            <p:ph type="sldNum" sz="quarter" idx="5"/>
-          </p:nvPr>
-        </p:nvSpPr>
-        <p:spPr/>
-        <p:txBody>
-          <a:bodyPr/>
-          <a:lstStyle/>
-          <a:p>
-            <a:fld id="{03F7FEAC-7D78-4C92-B820-5C978C5ED1B4}" type="slidenum">
-              <a:rPr lang="en-US" smtClean="0"/>
-              <a:t>30</a:t>
-            </a:fld>
-            <a:endParaRPr lang="en-US"/>
-          </a:p>
-        </p:txBody>
-      </p:sp>
-    </p:spTree>
-    <p:extLst>
-      <p:ext uri="{BB962C8B-B14F-4D97-AF65-F5344CB8AC3E}">
-        <p14:creationId xmlns:p14="http://schemas.microsoft.com/office/powerpoint/2010/main" val="1803431292"/>
-      </p:ext>
-    </p:extLst>
-  </p:cSld>
-  <p:clrMapOvr>
-    <a:masterClrMapping/>
-  </p:clrMapOvr>
-</p:notes>
-</file>
-
-<file path=ppt/notesSlides/notesSlide4.xml><?xml version="1.0" encoding="utf-8"?>
-<p:notes xmlns:a="http://schemas.openxmlformats.org/drawingml/2006/main" xmlns:r="http://schemas.openxmlformats.org/officeDocument/2006/relationships" xmlns:p="http://schemas.openxmlformats.org/presentationml/2006/main">
-  <p:cSld>
-    <p:spTree>
-      <p:nvGrpSpPr>
         <p:cNvPr id="1" name="">
           <a:extLst>
             <a:ext uri="{FF2B5EF4-FFF2-40B4-BE49-F238E27FC236}">
@@ -1197,7 +1065,7 @@
           <a:p>
             <a:fld id="{03F7FEAC-7D78-4C92-B820-5C978C5ED1B4}" type="slidenum">
               <a:rPr lang="en-US" smtClean="0"/>
-              <a:t>31</a:t>
+              <a:t>34</a:t>
             </a:fld>
             <a:endParaRPr lang="en-US"/>
           </a:p>
@@ -1207,6 +1075,90 @@
     <p:extLst>
       <p:ext uri="{BB962C8B-B14F-4D97-AF65-F5344CB8AC3E}">
         <p14:creationId xmlns:p14="http://schemas.microsoft.com/office/powerpoint/2010/main" val="2577078470"/>
+      </p:ext>
+    </p:extLst>
+  </p:cSld>
+  <p:clrMapOvr>
+    <a:masterClrMapping/>
+  </p:clrMapOvr>
+</p:notes>
+</file>
+
+<file path=ppt/notesSlides/notesSlide4.xml><?xml version="1.0" encoding="utf-8"?>
+<p:notes xmlns:a="http://schemas.openxmlformats.org/drawingml/2006/main" xmlns:r="http://schemas.openxmlformats.org/officeDocument/2006/relationships" xmlns:p="http://schemas.openxmlformats.org/presentationml/2006/main">
+  <p:cSld>
+    <p:spTree>
+      <p:nvGrpSpPr>
+        <p:cNvPr id="1" name=""/>
+        <p:cNvGrpSpPr/>
+        <p:nvPr/>
+      </p:nvGrpSpPr>
+      <p:grpSpPr>
+        <a:xfrm>
+          <a:off x="0" y="0"/>
+          <a:ext cx="0" cy="0"/>
+          <a:chOff x="0" y="0"/>
+          <a:chExt cx="0" cy="0"/>
+        </a:xfrm>
+      </p:grpSpPr>
+      <p:sp>
+        <p:nvSpPr>
+          <p:cNvPr id="2" name="Slide Image Placeholder 1"/>
+          <p:cNvSpPr>
+            <a:spLocks noGrp="1" noRot="1" noChangeAspect="1"/>
+          </p:cNvSpPr>
+          <p:nvPr>
+            <p:ph type="sldImg"/>
+          </p:nvPr>
+        </p:nvSpPr>
+        <p:spPr/>
+      </p:sp>
+      <p:sp>
+        <p:nvSpPr>
+          <p:cNvPr id="3" name="Notes Placeholder 2"/>
+          <p:cNvSpPr>
+            <a:spLocks noGrp="1"/>
+          </p:cNvSpPr>
+          <p:nvPr>
+            <p:ph type="body" idx="1"/>
+          </p:nvPr>
+        </p:nvSpPr>
+        <p:spPr/>
+        <p:txBody>
+          <a:bodyPr/>
+          <a:lstStyle/>
+          <a:p>
+            <a:endParaRPr lang="en-US" dirty="0"/>
+          </a:p>
+        </p:txBody>
+      </p:sp>
+      <p:sp>
+        <p:nvSpPr>
+          <p:cNvPr id="4" name="Slide Number Placeholder 3"/>
+          <p:cNvSpPr>
+            <a:spLocks noGrp="1"/>
+          </p:cNvSpPr>
+          <p:nvPr>
+            <p:ph type="sldNum" sz="quarter" idx="5"/>
+          </p:nvPr>
+        </p:nvSpPr>
+        <p:spPr/>
+        <p:txBody>
+          <a:bodyPr/>
+          <a:lstStyle/>
+          <a:p>
+            <a:fld id="{03F7FEAC-7D78-4C92-B820-5C978C5ED1B4}" type="slidenum">
+              <a:rPr lang="en-US" smtClean="0"/>
+              <a:t>35</a:t>
+            </a:fld>
+            <a:endParaRPr lang="en-US"/>
+          </a:p>
+        </p:txBody>
+      </p:sp>
+    </p:spTree>
+    <p:extLst>
+      <p:ext uri="{BB962C8B-B14F-4D97-AF65-F5344CB8AC3E}">
+        <p14:creationId xmlns:p14="http://schemas.microsoft.com/office/powerpoint/2010/main" val="1803431292"/>
       </p:ext>
     </p:extLst>
   </p:cSld>
@@ -1253,7 +1205,7 @@
             <a:fld id="{C761B540-B85A-48EC-9EF6-9AE02BDF169E}" type="slidenum">
               <a:rPr lang="en-US" smtClean="0"/>
               <a:pPr/>
-              <a:t>37</a:t>
+              <a:t>40</a:t>
             </a:fld>
             <a:endParaRPr lang="en-US"/>
           </a:p>
@@ -1355,7 +1307,7 @@
             <a:fld id="{BAFE06D5-8120-4702-8799-49873C1A47AF}" type="slidenum">
               <a:rPr lang="en-US" smtClean="0"/>
               <a:pPr/>
-              <a:t>39</a:t>
+              <a:t>42</a:t>
             </a:fld>
             <a:endParaRPr lang="en-US"/>
           </a:p>
@@ -1457,7 +1409,7 @@
             <a:fld id="{0F9BA69C-0CAC-4F69-8A3E-75C9C4CFA572}" type="slidenum">
               <a:rPr lang="en-US" smtClean="0"/>
               <a:pPr/>
-              <a:t>41</a:t>
+              <a:t>44</a:t>
             </a:fld>
             <a:endParaRPr lang="en-US"/>
           </a:p>
@@ -1701,7 +1653,7 @@
           <a:p>
             <a:fld id="{DE20BF63-FE06-4C95-BA80-0CD72D356A6A}" type="datetimeFigureOut">
               <a:rPr lang="en-US" smtClean="0"/>
-              <a:t>2/17/2026</a:t>
+              <a:t>5/28/2026</a:t>
             </a:fld>
             <a:endParaRPr lang="en-US"/>
           </a:p>
@@ -1864,7 +1816,7 @@
           <a:p>
             <a:fld id="{DE20BF63-FE06-4C95-BA80-0CD72D356A6A}" type="datetimeFigureOut">
               <a:rPr lang="en-US" smtClean="0"/>
-              <a:t>2/17/2026</a:t>
+              <a:t>5/28/2026</a:t>
             </a:fld>
             <a:endParaRPr lang="en-US"/>
           </a:p>
@@ -2037,7 +1989,7 @@
           <a:p>
             <a:fld id="{DE20BF63-FE06-4C95-BA80-0CD72D356A6A}" type="datetimeFigureOut">
               <a:rPr lang="en-US" smtClean="0"/>
-              <a:t>2/17/2026</a:t>
+              <a:t>5/28/2026</a:t>
             </a:fld>
             <a:endParaRPr lang="en-US"/>
           </a:p>
@@ -2432,7 +2384,7 @@
           <a:p>
             <a:fld id="{DE20BF63-FE06-4C95-BA80-0CD72D356A6A}" type="datetimeFigureOut">
               <a:rPr lang="en-US" smtClean="0"/>
-              <a:t>2/17/2026</a:t>
+              <a:t>5/28/2026</a:t>
             </a:fld>
             <a:endParaRPr lang="en-US"/>
           </a:p>
@@ -2672,7 +2624,7 @@
           <a:p>
             <a:fld id="{DE20BF63-FE06-4C95-BA80-0CD72D356A6A}" type="datetimeFigureOut">
               <a:rPr lang="en-US" smtClean="0"/>
-              <a:t>2/17/2026</a:t>
+              <a:t>5/28/2026</a:t>
             </a:fld>
             <a:endParaRPr lang="en-US"/>
           </a:p>
@@ -2952,7 +2904,7 @@
           <a:p>
             <a:fld id="{DE20BF63-FE06-4C95-BA80-0CD72D356A6A}" type="datetimeFigureOut">
               <a:rPr lang="en-US" smtClean="0"/>
-              <a:t>2/17/2026</a:t>
+              <a:t>5/28/2026</a:t>
             </a:fld>
             <a:endParaRPr lang="en-US"/>
           </a:p>
@@ -3366,7 +3318,7 @@
           <a:p>
             <a:fld id="{DE20BF63-FE06-4C95-BA80-0CD72D356A6A}" type="datetimeFigureOut">
               <a:rPr lang="en-US" smtClean="0"/>
-              <a:t>2/17/2026</a:t>
+              <a:t>5/28/2026</a:t>
             </a:fld>
             <a:endParaRPr lang="en-US"/>
           </a:p>
@@ -3478,7 +3430,7 @@
           <a:p>
             <a:fld id="{DE20BF63-FE06-4C95-BA80-0CD72D356A6A}" type="datetimeFigureOut">
               <a:rPr lang="en-US" smtClean="0"/>
-              <a:t>2/17/2026</a:t>
+              <a:t>5/28/2026</a:t>
             </a:fld>
             <a:endParaRPr lang="en-US"/>
           </a:p>
@@ -3568,7 +3520,7 @@
           <a:p>
             <a:fld id="{DE20BF63-FE06-4C95-BA80-0CD72D356A6A}" type="datetimeFigureOut">
               <a:rPr lang="en-US" smtClean="0"/>
-              <a:t>2/17/2026</a:t>
+              <a:t>5/28/2026</a:t>
             </a:fld>
             <a:endParaRPr lang="en-US"/>
           </a:p>
@@ -3838,7 +3790,7 @@
           <a:p>
             <a:fld id="{DE20BF63-FE06-4C95-BA80-0CD72D356A6A}" type="datetimeFigureOut">
               <a:rPr lang="en-US" smtClean="0"/>
-              <a:t>2/17/2026</a:t>
+              <a:t>5/28/2026</a:t>
             </a:fld>
             <a:endParaRPr lang="en-US"/>
           </a:p>
@@ -4085,7 +4037,7 @@
           <a:p>
             <a:fld id="{DE20BF63-FE06-4C95-BA80-0CD72D356A6A}" type="datetimeFigureOut">
               <a:rPr lang="en-US" smtClean="0"/>
-              <a:t>2/17/2026</a:t>
+              <a:t>5/28/2026</a:t>
             </a:fld>
             <a:endParaRPr lang="en-US"/>
           </a:p>
@@ -4291,7 +4243,7 @@
           <a:p>
             <a:fld id="{DE20BF63-FE06-4C95-BA80-0CD72D356A6A}" type="datetimeFigureOut">
               <a:rPr lang="en-US" smtClean="0"/>
-              <a:t>2/17/2026</a:t>
+              <a:t>5/28/2026</a:t>
             </a:fld>
             <a:endParaRPr lang="en-US"/>
           </a:p>
@@ -8719,36 +8671,18 @@
       </p:grpSpPr>
       <p:sp>
         <p:nvSpPr>
-          <p:cNvPr id="9218" name="Footer Placeholder 4"/>
+          <p:cNvPr id="2" name="Title 1">
+            <a:extLst>
+              <a:ext uri="{FF2B5EF4-FFF2-40B4-BE49-F238E27FC236}">
+                <a16:creationId xmlns:a16="http://schemas.microsoft.com/office/drawing/2014/main" id="{1062A867-10CE-CCEE-1AF5-5945F8C5CF81}"/>
+              </a:ext>
+            </a:extLst>
+          </p:cNvPr>
           <p:cNvSpPr>
             <a:spLocks noGrp="1"/>
           </p:cNvSpPr>
           <p:nvPr>
-            <p:ph type="ftr" sz="quarter" idx="11"/>
-          </p:nvPr>
-        </p:nvSpPr>
-        <p:spPr>
-          <a:noFill/>
-        </p:spPr>
-        <p:txBody>
-          <a:bodyPr/>
-          <a:lstStyle/>
-          <a:p>
-            <a:r>
-              <a:rPr lang="en-US"/>
-              <a:t>R. Todd Lines</a:t>
-            </a:r>
-          </a:p>
-        </p:txBody>
-      </p:sp>
-      <p:sp>
-        <p:nvSpPr>
-          <p:cNvPr id="9219" name="Rectangle 2"/>
-          <p:cNvSpPr>
-            <a:spLocks noGrp="1" noChangeArrowheads="1"/>
-          </p:cNvSpPr>
-          <p:nvPr>
-            <p:ph type="title"/>
+            <p:ph type="ctrTitle"/>
           </p:nvPr>
         </p:nvSpPr>
         <p:spPr/>
@@ -8756,22 +8690,27 @@
           <a:bodyPr/>
           <a:lstStyle/>
           <a:p>
-            <a:pPr eaLnBrk="1" hangingPunct="1"/>
-            <a:r>
-              <a:rPr lang="en-US"/>
-              <a:t>Simple Magnifier</a:t>
+            <a:r>
+              <a:rPr lang="en-US" dirty="0"/>
+              <a:t>END</a:t>
             </a:r>
           </a:p>
         </p:txBody>
       </p:sp>
       <p:sp>
         <p:nvSpPr>
-          <p:cNvPr id="9220" name="Rectangle 3"/>
+          <p:cNvPr id="3" name="Subtitle 2">
+            <a:extLst>
+              <a:ext uri="{FF2B5EF4-FFF2-40B4-BE49-F238E27FC236}">
+                <a16:creationId xmlns:a16="http://schemas.microsoft.com/office/drawing/2014/main" id="{B729B2DC-9D67-EA05-E426-34867E0B9300}"/>
+              </a:ext>
+            </a:extLst>
+          </p:cNvPr>
           <p:cNvSpPr>
-            <a:spLocks noGrp="1" noChangeArrowheads="1"/>
+            <a:spLocks noGrp="1"/>
           </p:cNvSpPr>
           <p:nvPr>
-            <p:ph type="body" idx="1"/>
+            <p:ph type="subTitle" idx="1"/>
           </p:nvPr>
         </p:nvSpPr>
         <p:spPr/>
@@ -8779,37 +8718,16 @@
           <a:bodyPr/>
           <a:lstStyle/>
           <a:p>
-            <a:pPr eaLnBrk="1" hangingPunct="1"/>
-            <a:r>
-              <a:rPr lang="en-US"/>
-              <a:t>A simple magnifier consists of a single converging lens</a:t>
-            </a:r>
-          </a:p>
-          <a:p>
-            <a:pPr eaLnBrk="1" hangingPunct="1"/>
-            <a:r>
-              <a:rPr lang="en-US"/>
-              <a:t>This device is used to increase the apparent size of an object</a:t>
-            </a:r>
-          </a:p>
-          <a:p>
-            <a:pPr eaLnBrk="1" hangingPunct="1"/>
-            <a:r>
-              <a:rPr lang="en-US"/>
-              <a:t>The size of an image formed on the retina depends on the angle subtended by the eye</a:t>
-            </a:r>
-          </a:p>
-          <a:p>
-            <a:pPr eaLnBrk="1" hangingPunct="1"/>
-            <a:endParaRPr lang="en-US"/>
-          </a:p>
-          <a:p>
-            <a:pPr eaLnBrk="1" hangingPunct="1"/>
             <a:endParaRPr lang="en-US"/>
           </a:p>
         </p:txBody>
       </p:sp>
     </p:spTree>
+    <p:extLst>
+      <p:ext uri="{BB962C8B-B14F-4D97-AF65-F5344CB8AC3E}">
+        <p14:creationId xmlns:p14="http://schemas.microsoft.com/office/powerpoint/2010/main" val="2869578996"/>
+      </p:ext>
+    </p:extLst>
   </p:cSld>
   <p:clrMapOvr>
     <a:masterClrMapping/>
@@ -8834,111 +8752,159 @@
           <a:chExt cx="0" cy="0"/>
         </a:xfrm>
       </p:grpSpPr>
+      <p:sp>
+        <p:nvSpPr>
+          <p:cNvPr id="9218" name="Footer Placeholder 4"/>
+          <p:cNvSpPr>
+            <a:spLocks noGrp="1"/>
+          </p:cNvSpPr>
+          <p:nvPr>
+            <p:ph type="ftr" sz="quarter" idx="11"/>
+          </p:nvPr>
+        </p:nvSpPr>
+        <p:spPr>
+          <a:noFill/>
+        </p:spPr>
+        <p:txBody>
+          <a:bodyPr/>
+          <a:lstStyle/>
+          <a:p>
+            <a:r>
+              <a:rPr lang="en-US"/>
+              <a:t>R. Todd Lines</a:t>
+            </a:r>
+          </a:p>
+        </p:txBody>
+      </p:sp>
+      <p:sp>
+        <p:nvSpPr>
+          <p:cNvPr id="9219" name="Rectangle 2"/>
+          <p:cNvSpPr>
+            <a:spLocks noGrp="1" noChangeArrowheads="1"/>
+          </p:cNvSpPr>
+          <p:nvPr>
+            <p:ph type="title"/>
+          </p:nvPr>
+        </p:nvSpPr>
+        <p:spPr/>
+        <p:txBody>
+          <a:bodyPr/>
+          <a:lstStyle/>
+          <a:p>
+            <a:pPr eaLnBrk="1" hangingPunct="1"/>
+            <a:r>
+              <a:rPr lang="en-US"/>
+              <a:t>Simple Magnifier</a:t>
+            </a:r>
+          </a:p>
+        </p:txBody>
+      </p:sp>
+      <p:sp>
+        <p:nvSpPr>
+          <p:cNvPr id="9220" name="Rectangle 3"/>
+          <p:cNvSpPr>
+            <a:spLocks noGrp="1" noChangeArrowheads="1"/>
+          </p:cNvSpPr>
+          <p:nvPr>
+            <p:ph type="body" idx="1"/>
+          </p:nvPr>
+        </p:nvSpPr>
+        <p:spPr/>
+        <p:txBody>
+          <a:bodyPr/>
+          <a:lstStyle/>
+          <a:p>
+            <a:pPr eaLnBrk="1" hangingPunct="1"/>
+            <a:r>
+              <a:rPr lang="en-US"/>
+              <a:t>A simple magnifier consists of a single converging lens</a:t>
+            </a:r>
+          </a:p>
+          <a:p>
+            <a:pPr eaLnBrk="1" hangingPunct="1"/>
+            <a:r>
+              <a:rPr lang="en-US"/>
+              <a:t>This device is used to increase the apparent size of an object</a:t>
+            </a:r>
+          </a:p>
+          <a:p>
+            <a:pPr eaLnBrk="1" hangingPunct="1"/>
+            <a:r>
+              <a:rPr lang="en-US"/>
+              <a:t>The size of an image formed on the retina depends on the angle subtended by the eye</a:t>
+            </a:r>
+          </a:p>
+          <a:p>
+            <a:pPr eaLnBrk="1" hangingPunct="1"/>
+            <a:endParaRPr lang="en-US"/>
+          </a:p>
+          <a:p>
+            <a:pPr eaLnBrk="1" hangingPunct="1"/>
+            <a:endParaRPr lang="en-US"/>
+          </a:p>
+        </p:txBody>
+      </p:sp>
+    </p:spTree>
+  </p:cSld>
+  <p:clrMapOvr>
+    <a:masterClrMapping/>
+  </p:clrMapOvr>
+</p:sld>
+</file>
+
+<file path=ppt/slides/slide28.xml><?xml version="1.0" encoding="utf-8"?>
+<p:sld xmlns:a="http://schemas.openxmlformats.org/drawingml/2006/main" xmlns:r="http://schemas.openxmlformats.org/officeDocument/2006/relationships" xmlns:p="http://schemas.openxmlformats.org/presentationml/2006/main">
+  <p:cSld>
+    <p:spTree>
+      <p:nvGrpSpPr>
+        <p:cNvPr id="1" name=""/>
+        <p:cNvGrpSpPr/>
+        <p:nvPr/>
+      </p:nvGrpSpPr>
+      <p:grpSpPr>
+        <a:xfrm>
+          <a:off x="0" y="0"/>
+          <a:ext cx="0" cy="0"/>
+          <a:chOff x="0" y="0"/>
+          <a:chExt cx="0" cy="0"/>
+        </a:xfrm>
+      </p:grpSpPr>
       <p:pic>
         <p:nvPicPr>
-          <p:cNvPr id="8194" name="Picture 2"/>
+          <p:cNvPr id="4" name="Graphic 3">
+            <a:extLst>
+              <a:ext uri="{FF2B5EF4-FFF2-40B4-BE49-F238E27FC236}">
+                <a16:creationId xmlns:a16="http://schemas.microsoft.com/office/drawing/2014/main" id="{8024B42E-0A7C-27DA-0B98-EB93CC4DE964}"/>
+              </a:ext>
+            </a:extLst>
+          </p:cNvPr>
           <p:cNvPicPr>
-            <a:picLocks noChangeAspect="1" noChangeArrowheads="1"/>
+            <a:picLocks noChangeAspect="1"/>
           </p:cNvPicPr>
           <p:nvPr/>
         </p:nvPicPr>
         <p:blipFill>
-          <a:blip r:embed="rId2">
+          <a:blip>
             <a:extLst>
-              <a:ext uri="{28A0092B-C50C-407E-A947-70E740481C1C}">
-                <a14:useLocalDpi xmlns:a14="http://schemas.microsoft.com/office/drawing/2010/main" val="0"/>
+              <a:ext uri="{96DAC541-7B7A-43D3-8B79-37D633B846F1}">
+                <asvg:svgBlip xmlns:asvg="http://schemas.microsoft.com/office/drawing/2016/SVG/main" r:embed="rId2"/>
               </a:ext>
             </a:extLst>
           </a:blip>
-          <a:srcRect/>
           <a:stretch>
             <a:fillRect/>
           </a:stretch>
         </p:blipFill>
-        <p:spPr bwMode="auto">
+        <p:spPr>
           <a:xfrm>
-            <a:off x="533400" y="2009774"/>
-            <a:ext cx="8294230" cy="2200275"/>
+            <a:off x="842962" y="2471737"/>
+            <a:ext cx="7458075" cy="1914525"/>
           </a:xfrm>
           <a:prstGeom prst="rect">
             <a:avLst/>
           </a:prstGeom>
-          <a:noFill/>
-          <a:ln>
-            <a:noFill/>
-          </a:ln>
-          <a:effectLst/>
-          <a:extLst>
-            <a:ext uri="{909E8E84-426E-40DD-AFC4-6F175D3DCCD1}">
-              <a14:hiddenFill xmlns:a14="http://schemas.microsoft.com/office/drawing/2010/main">
-                <a:solidFill>
-                  <a:schemeClr val="accent1"/>
-                </a:solidFill>
-              </a14:hiddenFill>
-            </a:ext>
-            <a:ext uri="{91240B29-F687-4F45-9708-019B960494DF}">
-              <a14:hiddenLine xmlns:a14="http://schemas.microsoft.com/office/drawing/2010/main" w="9525">
-                <a:solidFill>
-                  <a:schemeClr val="tx1"/>
-                </a:solidFill>
-                <a:miter lim="800000"/>
-                <a:headEnd/>
-                <a:tailEnd/>
-              </a14:hiddenLine>
-            </a:ext>
-            <a:ext uri="{AF507438-7753-43E0-B8FC-AC1667EBCBE1}">
-              <a14:hiddenEffects xmlns:a14="http://schemas.microsoft.com/office/drawing/2010/main">
-                <a:effectLst>
-                  <a:outerShdw dist="35921" dir="2700000" algn="ctr" rotWithShape="0">
-                    <a:schemeClr val="bg2"/>
-                  </a:outerShdw>
-                </a:effectLst>
-              </a14:hiddenEffects>
-            </a:ext>
-          </a:extLst>
         </p:spPr>
       </p:pic>
-      <p:sp>
-        <p:nvSpPr>
-          <p:cNvPr id="2" name="TextBox 1">
-            <a:extLst>
-              <a:ext uri="{FF2B5EF4-FFF2-40B4-BE49-F238E27FC236}">
-                <a16:creationId xmlns:a16="http://schemas.microsoft.com/office/drawing/2014/main" id="{6516F8DD-C01D-5C7C-FEB8-2C902B1BA7F1}"/>
-              </a:ext>
-            </a:extLst>
-          </p:cNvPr>
-          <p:cNvSpPr txBox="1"/>
-          <p:nvPr/>
-        </p:nvSpPr>
-        <p:spPr>
-          <a:xfrm>
-            <a:off x="8505721" y="2711514"/>
-            <a:ext cx="500458" cy="523220"/>
-          </a:xfrm>
-          <a:prstGeom prst="rect">
-            <a:avLst/>
-          </a:prstGeom>
-          <a:solidFill>
-            <a:schemeClr val="bg1"/>
-          </a:solidFill>
-        </p:spPr>
-        <p:txBody>
-          <a:bodyPr wrap="none" rtlCol="0">
-            <a:spAutoFit/>
-          </a:bodyPr>
-          <a:lstStyle/>
-          <a:p>
-            <a:r>
-              <a:rPr lang="en-US" sz="2800" dirty="0"/>
-              <a:t>h</a:t>
-            </a:r>
-            <a:r>
-              <a:rPr lang="en-US" sz="2800" baseline="-25000" dirty="0"/>
-              <a:t>o</a:t>
-            </a:r>
-          </a:p>
-        </p:txBody>
-      </p:sp>
     </p:spTree>
     <p:extLst>
       <p:ext uri="{BB962C8B-B14F-4D97-AF65-F5344CB8AC3E}">
@@ -8952,7 +8918,7 @@
 </p:sld>
 </file>
 
-<file path=ppt/slides/slide28.xml><?xml version="1.0" encoding="utf-8"?>
+<file path=ppt/slides/slide29.xml><?xml version="1.0" encoding="utf-8"?>
 <p:sld xmlns:a="http://schemas.openxmlformats.org/drawingml/2006/main" xmlns:r="http://schemas.openxmlformats.org/officeDocument/2006/relationships" xmlns:p="http://schemas.openxmlformats.org/presentationml/2006/main">
   <p:cSld>
     <p:spTree>
@@ -8985,7 +8951,7 @@
         </p:blipFill>
         <p:spPr>
           <a:xfrm>
-            <a:off x="609790" y="1320774"/>
+            <a:off x="609790" y="1332064"/>
             <a:ext cx="7924419" cy="4374414"/>
           </a:xfrm>
           <a:prstGeom prst="rect">
@@ -9088,7 +9054,150 @@
 </p:sld>
 </file>
 
-<file path=ppt/slides/slide29.xml><?xml version="1.0" encoding="utf-8"?>
+<file path=ppt/slides/slide3.xml><?xml version="1.0" encoding="utf-8"?>
+<p:sld xmlns:a="http://schemas.openxmlformats.org/drawingml/2006/main" xmlns:r="http://schemas.openxmlformats.org/officeDocument/2006/relationships" xmlns:p="http://schemas.openxmlformats.org/presentationml/2006/main">
+  <p:cSld>
+    <p:spTree>
+      <p:nvGrpSpPr>
+        <p:cNvPr id="1" name=""/>
+        <p:cNvGrpSpPr/>
+        <p:nvPr/>
+      </p:nvGrpSpPr>
+      <p:grpSpPr>
+        <a:xfrm>
+          <a:off x="0" y="0"/>
+          <a:ext cx="0" cy="0"/>
+          <a:chOff x="0" y="0"/>
+          <a:chExt cx="0" cy="0"/>
+        </a:xfrm>
+      </p:grpSpPr>
+      <p:pic>
+        <p:nvPicPr>
+          <p:cNvPr id="3" name="Picture 2">
+            <a:extLst>
+              <a:ext uri="{FF2B5EF4-FFF2-40B4-BE49-F238E27FC236}">
+                <a16:creationId xmlns:a16="http://schemas.microsoft.com/office/drawing/2014/main" id="{695638B6-2773-E6A8-22F7-4C7809473FAC}"/>
+              </a:ext>
+            </a:extLst>
+          </p:cNvPr>
+          <p:cNvPicPr>
+            <a:picLocks noChangeAspect="1" noChangeArrowheads="1"/>
+          </p:cNvPicPr>
+          <p:nvPr/>
+        </p:nvPicPr>
+        <p:blipFill>
+          <a:blip r:embed="rId2">
+            <a:extLst>
+              <a:ext uri="{28A0092B-C50C-407E-A947-70E740481C1C}">
+                <a14:useLocalDpi xmlns:a14="http://schemas.microsoft.com/office/drawing/2010/main" val="0"/>
+              </a:ext>
+            </a:extLst>
+          </a:blip>
+          <a:srcRect/>
+          <a:stretch>
+            <a:fillRect/>
+          </a:stretch>
+        </p:blipFill>
+        <p:spPr bwMode="auto">
+          <a:xfrm>
+            <a:off x="1143000" y="1053156"/>
+            <a:ext cx="6858000" cy="4622293"/>
+          </a:xfrm>
+          <a:prstGeom prst="rect">
+            <a:avLst/>
+          </a:prstGeom>
+          <a:noFill/>
+          <a:extLst>
+            <a:ext uri="{909E8E84-426E-40DD-AFC4-6F175D3DCCD1}">
+              <a14:hiddenFill xmlns:a14="http://schemas.microsoft.com/office/drawing/2010/main">
+                <a:solidFill>
+                  <a:srgbClr val="FFFFFF"/>
+                </a:solidFill>
+              </a14:hiddenFill>
+            </a:ext>
+          </a:extLst>
+        </p:spPr>
+      </p:pic>
+    </p:spTree>
+    <p:extLst>
+      <p:ext uri="{BB962C8B-B14F-4D97-AF65-F5344CB8AC3E}">
+        <p14:creationId xmlns:p14="http://schemas.microsoft.com/office/powerpoint/2010/main" val="4174033270"/>
+      </p:ext>
+    </p:extLst>
+  </p:cSld>
+  <p:clrMapOvr>
+    <a:masterClrMapping/>
+  </p:clrMapOvr>
+</p:sld>
+</file>
+
+<file path=ppt/slides/slide30.xml><?xml version="1.0" encoding="utf-8"?>
+<p:sld xmlns:a="http://schemas.openxmlformats.org/drawingml/2006/main" xmlns:r="http://schemas.openxmlformats.org/officeDocument/2006/relationships" xmlns:p="http://schemas.openxmlformats.org/presentationml/2006/main">
+  <p:cSld>
+    <p:spTree>
+      <p:nvGrpSpPr>
+        <p:cNvPr id="1" name=""/>
+        <p:cNvGrpSpPr/>
+        <p:nvPr/>
+      </p:nvGrpSpPr>
+      <p:grpSpPr>
+        <a:xfrm>
+          <a:off x="0" y="0"/>
+          <a:ext cx="0" cy="0"/>
+          <a:chOff x="0" y="0"/>
+          <a:chExt cx="0" cy="0"/>
+        </a:xfrm>
+      </p:grpSpPr>
+      <p:pic>
+        <p:nvPicPr>
+          <p:cNvPr id="20" name="Graphic 19">
+            <a:extLst>
+              <a:ext uri="{FF2B5EF4-FFF2-40B4-BE49-F238E27FC236}">
+                <a16:creationId xmlns:a16="http://schemas.microsoft.com/office/drawing/2014/main" id="{E0466E5D-6BA8-A757-B9F0-CFBBA6BAB41C}"/>
+              </a:ext>
+            </a:extLst>
+          </p:cNvPr>
+          <p:cNvPicPr>
+            <a:picLocks noChangeAspect="1"/>
+          </p:cNvPicPr>
+          <p:nvPr/>
+        </p:nvPicPr>
+        <p:blipFill>
+          <a:blip>
+            <a:extLst>
+              <a:ext uri="{96DAC541-7B7A-43D3-8B79-37D633B846F1}">
+                <asvg:svgBlip xmlns:asvg="http://schemas.microsoft.com/office/drawing/2016/SVG/main" r:embed="rId2"/>
+              </a:ext>
+            </a:extLst>
+          </a:blip>
+          <a:stretch>
+            <a:fillRect/>
+          </a:stretch>
+        </p:blipFill>
+        <p:spPr>
+          <a:xfrm>
+            <a:off x="189939" y="1121259"/>
+            <a:ext cx="9144000" cy="4315589"/>
+          </a:xfrm>
+          <a:prstGeom prst="rect">
+            <a:avLst/>
+          </a:prstGeom>
+        </p:spPr>
+      </p:pic>
+    </p:spTree>
+    <p:extLst>
+      <p:ext uri="{BB962C8B-B14F-4D97-AF65-F5344CB8AC3E}">
+        <p14:creationId xmlns:p14="http://schemas.microsoft.com/office/powerpoint/2010/main" val="1379264335"/>
+      </p:ext>
+    </p:extLst>
+  </p:cSld>
+  <p:clrMapOvr>
+    <a:masterClrMapping/>
+  </p:clrMapOvr>
+</p:sld>
+</file>
+
+<file path=ppt/slides/slide31.xml><?xml version="1.0" encoding="utf-8"?>
 <p:sld xmlns:a="http://schemas.openxmlformats.org/drawingml/2006/main" xmlns:r="http://schemas.openxmlformats.org/officeDocument/2006/relationships" xmlns:p="http://schemas.openxmlformats.org/presentationml/2006/main">
   <p:cSld>
     <p:spTree>
@@ -9586,7 +9695,7 @@
 </p:sld>
 </file>
 
-<file path=ppt/slides/slide3.xml><?xml version="1.0" encoding="utf-8"?>
+<file path=ppt/slides/slide32.xml><?xml version="1.0" encoding="utf-8"?>
 <p:sld xmlns:a="http://schemas.openxmlformats.org/drawingml/2006/main" xmlns:r="http://schemas.openxmlformats.org/officeDocument/2006/relationships" xmlns:p="http://schemas.openxmlformats.org/presentationml/2006/main">
   <p:cSld>
     <p:spTree>
@@ -9605,55 +9714,44 @@
       </p:grpSpPr>
       <p:pic>
         <p:nvPicPr>
-          <p:cNvPr id="3" name="Picture 2">
+          <p:cNvPr id="17" name="Graphic 16">
             <a:extLst>
               <a:ext uri="{FF2B5EF4-FFF2-40B4-BE49-F238E27FC236}">
-                <a16:creationId xmlns:a16="http://schemas.microsoft.com/office/drawing/2014/main" id="{695638B6-2773-E6A8-22F7-4C7809473FAC}"/>
+                <a16:creationId xmlns:a16="http://schemas.microsoft.com/office/drawing/2014/main" id="{940E75BB-EFFD-69F7-284A-43B9F6136695}"/>
               </a:ext>
             </a:extLst>
           </p:cNvPr>
           <p:cNvPicPr>
-            <a:picLocks noChangeAspect="1" noChangeArrowheads="1"/>
+            <a:picLocks noChangeAspect="1"/>
           </p:cNvPicPr>
           <p:nvPr/>
         </p:nvPicPr>
         <p:blipFill>
-          <a:blip r:embed="rId2">
+          <a:blip>
             <a:extLst>
-              <a:ext uri="{28A0092B-C50C-407E-A947-70E740481C1C}">
-                <a14:useLocalDpi xmlns:a14="http://schemas.microsoft.com/office/drawing/2010/main" val="0"/>
+              <a:ext uri="{96DAC541-7B7A-43D3-8B79-37D633B846F1}">
+                <asvg:svgBlip xmlns:asvg="http://schemas.microsoft.com/office/drawing/2016/SVG/main" r:embed="rId2"/>
               </a:ext>
             </a:extLst>
           </a:blip>
-          <a:srcRect/>
           <a:stretch>
             <a:fillRect/>
           </a:stretch>
         </p:blipFill>
-        <p:spPr bwMode="auto">
+        <p:spPr>
           <a:xfrm>
-            <a:off x="1143000" y="1053156"/>
-            <a:ext cx="6858000" cy="4622293"/>
+            <a:off x="90311" y="341305"/>
+            <a:ext cx="9144000" cy="4621647"/>
           </a:xfrm>
           <a:prstGeom prst="rect">
             <a:avLst/>
           </a:prstGeom>
-          <a:noFill/>
-          <a:extLst>
-            <a:ext uri="{909E8E84-426E-40DD-AFC4-6F175D3DCCD1}">
-              <a14:hiddenFill xmlns:a14="http://schemas.microsoft.com/office/drawing/2010/main">
-                <a:solidFill>
-                  <a:srgbClr val="FFFFFF"/>
-                </a:solidFill>
-              </a14:hiddenFill>
-            </a:ext>
-          </a:extLst>
         </p:spPr>
       </p:pic>
     </p:spTree>
     <p:extLst>
       <p:ext uri="{BB962C8B-B14F-4D97-AF65-F5344CB8AC3E}">
-        <p14:creationId xmlns:p14="http://schemas.microsoft.com/office/powerpoint/2010/main" val="4174033270"/>
+        <p14:creationId xmlns:p14="http://schemas.microsoft.com/office/powerpoint/2010/main" val="81451399"/>
       </p:ext>
     </p:extLst>
   </p:cSld>
@@ -9663,7 +9761,1149 @@
 </p:sld>
 </file>
 
-<file path=ppt/slides/slide30.xml><?xml version="1.0" encoding="utf-8"?>
+<file path=ppt/slides/slide33.xml><?xml version="1.0" encoding="utf-8"?>
+<p:sld xmlns:a="http://schemas.openxmlformats.org/drawingml/2006/main" xmlns:r="http://schemas.openxmlformats.org/officeDocument/2006/relationships" xmlns:p="http://schemas.openxmlformats.org/presentationml/2006/main">
+  <p:cSld>
+    <p:spTree>
+      <p:nvGrpSpPr>
+        <p:cNvPr id="1" name=""/>
+        <p:cNvGrpSpPr/>
+        <p:nvPr/>
+      </p:nvGrpSpPr>
+      <p:grpSpPr>
+        <a:xfrm>
+          <a:off x="0" y="0"/>
+          <a:ext cx="0" cy="0"/>
+          <a:chOff x="0" y="0"/>
+          <a:chExt cx="0" cy="0"/>
+        </a:xfrm>
+      </p:grpSpPr>
+      <p:pic>
+        <p:nvPicPr>
+          <p:cNvPr id="17" name="Graphic 16">
+            <a:extLst>
+              <a:ext uri="{FF2B5EF4-FFF2-40B4-BE49-F238E27FC236}">
+                <a16:creationId xmlns:a16="http://schemas.microsoft.com/office/drawing/2014/main" id="{8CE27FC2-0AA0-9EE0-BCF1-9E04B0185F2C}"/>
+              </a:ext>
+            </a:extLst>
+          </p:cNvPr>
+          <p:cNvPicPr>
+            <a:picLocks noChangeAspect="1"/>
+          </p:cNvPicPr>
+          <p:nvPr/>
+        </p:nvPicPr>
+        <p:blipFill>
+          <a:blip>
+            <a:extLst>
+              <a:ext uri="{96DAC541-7B7A-43D3-8B79-37D633B846F1}">
+                <asvg:svgBlip xmlns:asvg="http://schemas.microsoft.com/office/drawing/2016/SVG/main" r:embed="rId2"/>
+              </a:ext>
+            </a:extLst>
+          </a:blip>
+          <a:stretch>
+            <a:fillRect/>
+          </a:stretch>
+        </p:blipFill>
+        <p:spPr>
+          <a:xfrm>
+            <a:off x="924532" y="0"/>
+            <a:ext cx="7294936" cy="6858000"/>
+          </a:xfrm>
+          <a:prstGeom prst="rect">
+            <a:avLst/>
+          </a:prstGeom>
+        </p:spPr>
+      </p:pic>
+      <p:grpSp>
+        <p:nvGrpSpPr>
+          <p:cNvPr id="9" name="Group 8">
+            <a:extLst>
+              <a:ext uri="{FF2B5EF4-FFF2-40B4-BE49-F238E27FC236}">
+                <a16:creationId xmlns:a16="http://schemas.microsoft.com/office/drawing/2014/main" id="{E447808C-FB77-A0F5-6182-3F6E360A15F2}"/>
+              </a:ext>
+            </a:extLst>
+          </p:cNvPr>
+          <p:cNvGrpSpPr/>
+          <p:nvPr/>
+        </p:nvGrpSpPr>
+        <p:grpSpPr>
+          <a:xfrm>
+            <a:off x="1761067" y="1298222"/>
+            <a:ext cx="1281289" cy="609600"/>
+            <a:chOff x="1761067" y="1298222"/>
+            <a:chExt cx="1281289" cy="609600"/>
+          </a:xfrm>
+        </p:grpSpPr>
+        <p:cxnSp>
+          <p:nvCxnSpPr>
+            <p:cNvPr id="3" name="Straight Connector 2">
+              <a:extLst>
+                <a:ext uri="{FF2B5EF4-FFF2-40B4-BE49-F238E27FC236}">
+                  <a16:creationId xmlns:a16="http://schemas.microsoft.com/office/drawing/2014/main" id="{30C16A0F-E1E8-33C4-A992-D3D9B94FCA4F}"/>
+                </a:ext>
+              </a:extLst>
+            </p:cNvPr>
+            <p:cNvCxnSpPr>
+              <a:cxnSpLocks/>
+            </p:cNvCxnSpPr>
+            <p:nvPr/>
+          </p:nvCxnSpPr>
+          <p:spPr>
+            <a:xfrm>
+              <a:off x="1761067" y="1298222"/>
+              <a:ext cx="0" cy="609600"/>
+            </a:xfrm>
+            <a:prstGeom prst="line">
+              <a:avLst/>
+            </a:prstGeom>
+          </p:spPr>
+          <p:style>
+            <a:lnRef idx="1">
+              <a:schemeClr val="dk1"/>
+            </a:lnRef>
+            <a:fillRef idx="0">
+              <a:schemeClr val="dk1"/>
+            </a:fillRef>
+            <a:effectRef idx="0">
+              <a:schemeClr val="dk1"/>
+            </a:effectRef>
+            <a:fontRef idx="minor">
+              <a:schemeClr val="tx1"/>
+            </a:fontRef>
+          </p:style>
+        </p:cxnSp>
+        <p:cxnSp>
+          <p:nvCxnSpPr>
+            <p:cNvPr id="4" name="Straight Connector 3">
+              <a:extLst>
+                <a:ext uri="{FF2B5EF4-FFF2-40B4-BE49-F238E27FC236}">
+                  <a16:creationId xmlns:a16="http://schemas.microsoft.com/office/drawing/2014/main" id="{745CADA5-E28F-06EE-5B64-45FA731C7E72}"/>
+                </a:ext>
+              </a:extLst>
+            </p:cNvPr>
+            <p:cNvCxnSpPr>
+              <a:cxnSpLocks/>
+            </p:cNvCxnSpPr>
+            <p:nvPr/>
+          </p:nvCxnSpPr>
+          <p:spPr>
+            <a:xfrm>
+              <a:off x="3042356" y="1298222"/>
+              <a:ext cx="0" cy="609600"/>
+            </a:xfrm>
+            <a:prstGeom prst="line">
+              <a:avLst/>
+            </a:prstGeom>
+          </p:spPr>
+          <p:style>
+            <a:lnRef idx="1">
+              <a:schemeClr val="dk1"/>
+            </a:lnRef>
+            <a:fillRef idx="0">
+              <a:schemeClr val="dk1"/>
+            </a:fillRef>
+            <a:effectRef idx="0">
+              <a:schemeClr val="dk1"/>
+            </a:effectRef>
+            <a:fontRef idx="minor">
+              <a:schemeClr val="tx1"/>
+            </a:fontRef>
+          </p:style>
+        </p:cxnSp>
+        <p:cxnSp>
+          <p:nvCxnSpPr>
+            <p:cNvPr id="6" name="Straight Arrow Connector 5">
+              <a:extLst>
+                <a:ext uri="{FF2B5EF4-FFF2-40B4-BE49-F238E27FC236}">
+                  <a16:creationId xmlns:a16="http://schemas.microsoft.com/office/drawing/2014/main" id="{34007F80-DF72-CE6F-D5EC-E7C477A521A8}"/>
+                </a:ext>
+              </a:extLst>
+            </p:cNvPr>
+            <p:cNvCxnSpPr>
+              <a:cxnSpLocks/>
+            </p:cNvCxnSpPr>
+            <p:nvPr/>
+          </p:nvCxnSpPr>
+          <p:spPr>
+            <a:xfrm>
+              <a:off x="1761067" y="1636888"/>
+              <a:ext cx="1281289" cy="0"/>
+            </a:xfrm>
+            <a:prstGeom prst="straightConnector1">
+              <a:avLst/>
+            </a:prstGeom>
+            <a:ln w="22225">
+              <a:headEnd type="stealth"/>
+              <a:tailEnd type="stealth"/>
+            </a:ln>
+          </p:spPr>
+          <p:style>
+            <a:lnRef idx="1">
+              <a:schemeClr val="dk1"/>
+            </a:lnRef>
+            <a:fillRef idx="0">
+              <a:schemeClr val="dk1"/>
+            </a:fillRef>
+            <a:effectRef idx="0">
+              <a:schemeClr val="dk1"/>
+            </a:effectRef>
+            <a:fontRef idx="minor">
+              <a:schemeClr val="tx1"/>
+            </a:fontRef>
+          </p:style>
+        </p:cxnSp>
+        <p:sp>
+          <p:nvSpPr>
+            <p:cNvPr id="8" name="TextBox 7">
+              <a:extLst>
+                <a:ext uri="{FF2B5EF4-FFF2-40B4-BE49-F238E27FC236}">
+                  <a16:creationId xmlns:a16="http://schemas.microsoft.com/office/drawing/2014/main" id="{29370AAA-5077-E913-FEFD-E38F3B8C5DF4}"/>
+                </a:ext>
+              </a:extLst>
+            </p:cNvPr>
+            <p:cNvSpPr txBox="1"/>
+            <p:nvPr/>
+          </p:nvSpPr>
+          <p:spPr>
+            <a:xfrm>
+              <a:off x="2248464" y="1538490"/>
+              <a:ext cx="306494" cy="369332"/>
+            </a:xfrm>
+            <a:prstGeom prst="rect">
+              <a:avLst/>
+            </a:prstGeom>
+            <a:solidFill>
+              <a:schemeClr val="bg1"/>
+            </a:solidFill>
+          </p:spPr>
+          <p:txBody>
+            <a:bodyPr wrap="none" rtlCol="0">
+              <a:spAutoFit/>
+            </a:bodyPr>
+            <a:lstStyle/>
+            <a:p>
+              <a:r>
+                <a:rPr lang="en-US" dirty="0"/>
+                <a:t>d</a:t>
+              </a:r>
+            </a:p>
+          </p:txBody>
+        </p:sp>
+      </p:grpSp>
+      <p:grpSp>
+        <p:nvGrpSpPr>
+          <p:cNvPr id="10" name="Group 9">
+            <a:extLst>
+              <a:ext uri="{FF2B5EF4-FFF2-40B4-BE49-F238E27FC236}">
+                <a16:creationId xmlns:a16="http://schemas.microsoft.com/office/drawing/2014/main" id="{62D75928-C2AA-A496-70B2-8DA1D6E9233B}"/>
+              </a:ext>
+            </a:extLst>
+          </p:cNvPr>
+          <p:cNvGrpSpPr/>
+          <p:nvPr/>
+        </p:nvGrpSpPr>
+        <p:grpSpPr>
+          <a:xfrm>
+            <a:off x="1652975" y="4916312"/>
+            <a:ext cx="1281289" cy="609600"/>
+            <a:chOff x="1761067" y="1298222"/>
+            <a:chExt cx="1281289" cy="609600"/>
+          </a:xfrm>
+        </p:grpSpPr>
+        <p:cxnSp>
+          <p:nvCxnSpPr>
+            <p:cNvPr id="11" name="Straight Connector 10">
+              <a:extLst>
+                <a:ext uri="{FF2B5EF4-FFF2-40B4-BE49-F238E27FC236}">
+                  <a16:creationId xmlns:a16="http://schemas.microsoft.com/office/drawing/2014/main" id="{C8056505-7A0A-4AD6-CF72-D15F6DE0ACC1}"/>
+                </a:ext>
+              </a:extLst>
+            </p:cNvPr>
+            <p:cNvCxnSpPr>
+              <a:cxnSpLocks/>
+            </p:cNvCxnSpPr>
+            <p:nvPr/>
+          </p:nvCxnSpPr>
+          <p:spPr>
+            <a:xfrm>
+              <a:off x="1761067" y="1298222"/>
+              <a:ext cx="0" cy="609600"/>
+            </a:xfrm>
+            <a:prstGeom prst="line">
+              <a:avLst/>
+            </a:prstGeom>
+          </p:spPr>
+          <p:style>
+            <a:lnRef idx="1">
+              <a:schemeClr val="dk1"/>
+            </a:lnRef>
+            <a:fillRef idx="0">
+              <a:schemeClr val="dk1"/>
+            </a:fillRef>
+            <a:effectRef idx="0">
+              <a:schemeClr val="dk1"/>
+            </a:effectRef>
+            <a:fontRef idx="minor">
+              <a:schemeClr val="tx1"/>
+            </a:fontRef>
+          </p:style>
+        </p:cxnSp>
+        <p:cxnSp>
+          <p:nvCxnSpPr>
+            <p:cNvPr id="12" name="Straight Connector 11">
+              <a:extLst>
+                <a:ext uri="{FF2B5EF4-FFF2-40B4-BE49-F238E27FC236}">
+                  <a16:creationId xmlns:a16="http://schemas.microsoft.com/office/drawing/2014/main" id="{E909BCC5-ED11-0400-14EF-21C327334430}"/>
+                </a:ext>
+              </a:extLst>
+            </p:cNvPr>
+            <p:cNvCxnSpPr>
+              <a:cxnSpLocks/>
+            </p:cNvCxnSpPr>
+            <p:nvPr/>
+          </p:nvCxnSpPr>
+          <p:spPr>
+            <a:xfrm>
+              <a:off x="3042356" y="1298222"/>
+              <a:ext cx="0" cy="609600"/>
+            </a:xfrm>
+            <a:prstGeom prst="line">
+              <a:avLst/>
+            </a:prstGeom>
+          </p:spPr>
+          <p:style>
+            <a:lnRef idx="1">
+              <a:schemeClr val="dk1"/>
+            </a:lnRef>
+            <a:fillRef idx="0">
+              <a:schemeClr val="dk1"/>
+            </a:fillRef>
+            <a:effectRef idx="0">
+              <a:schemeClr val="dk1"/>
+            </a:effectRef>
+            <a:fontRef idx="minor">
+              <a:schemeClr val="tx1"/>
+            </a:fontRef>
+          </p:style>
+        </p:cxnSp>
+        <p:cxnSp>
+          <p:nvCxnSpPr>
+            <p:cNvPr id="13" name="Straight Arrow Connector 12">
+              <a:extLst>
+                <a:ext uri="{FF2B5EF4-FFF2-40B4-BE49-F238E27FC236}">
+                  <a16:creationId xmlns:a16="http://schemas.microsoft.com/office/drawing/2014/main" id="{E623E685-7FCD-8BAC-2334-9C02D2EB3EAE}"/>
+                </a:ext>
+              </a:extLst>
+            </p:cNvPr>
+            <p:cNvCxnSpPr>
+              <a:cxnSpLocks/>
+            </p:cNvCxnSpPr>
+            <p:nvPr/>
+          </p:nvCxnSpPr>
+          <p:spPr>
+            <a:xfrm>
+              <a:off x="1761067" y="1636888"/>
+              <a:ext cx="1281289" cy="0"/>
+            </a:xfrm>
+            <a:prstGeom prst="straightConnector1">
+              <a:avLst/>
+            </a:prstGeom>
+            <a:ln w="22225">
+              <a:headEnd type="stealth"/>
+              <a:tailEnd type="stealth"/>
+            </a:ln>
+          </p:spPr>
+          <p:style>
+            <a:lnRef idx="1">
+              <a:schemeClr val="dk1"/>
+            </a:lnRef>
+            <a:fillRef idx="0">
+              <a:schemeClr val="dk1"/>
+            </a:fillRef>
+            <a:effectRef idx="0">
+              <a:schemeClr val="dk1"/>
+            </a:effectRef>
+            <a:fontRef idx="minor">
+              <a:schemeClr val="tx1"/>
+            </a:fontRef>
+          </p:style>
+        </p:cxnSp>
+        <p:sp>
+          <p:nvSpPr>
+            <p:cNvPr id="14" name="TextBox 13">
+              <a:extLst>
+                <a:ext uri="{FF2B5EF4-FFF2-40B4-BE49-F238E27FC236}">
+                  <a16:creationId xmlns:a16="http://schemas.microsoft.com/office/drawing/2014/main" id="{9B5C2FDC-CE19-4101-06E5-4E873244FDC0}"/>
+                </a:ext>
+              </a:extLst>
+            </p:cNvPr>
+            <p:cNvSpPr txBox="1"/>
+            <p:nvPr/>
+          </p:nvSpPr>
+          <p:spPr>
+            <a:xfrm>
+              <a:off x="2248464" y="1538490"/>
+              <a:ext cx="306494" cy="369332"/>
+            </a:xfrm>
+            <a:prstGeom prst="rect">
+              <a:avLst/>
+            </a:prstGeom>
+            <a:solidFill>
+              <a:schemeClr val="bg1"/>
+            </a:solidFill>
+          </p:spPr>
+          <p:txBody>
+            <a:bodyPr wrap="none" rtlCol="0">
+              <a:spAutoFit/>
+            </a:bodyPr>
+            <a:lstStyle/>
+            <a:p>
+              <a:r>
+                <a:rPr lang="en-US" dirty="0"/>
+                <a:t>d</a:t>
+              </a:r>
+            </a:p>
+          </p:txBody>
+        </p:sp>
+      </p:grpSp>
+    </p:spTree>
+    <p:extLst>
+      <p:ext uri="{BB962C8B-B14F-4D97-AF65-F5344CB8AC3E}">
+        <p14:creationId xmlns:p14="http://schemas.microsoft.com/office/powerpoint/2010/main" val="1314439450"/>
+      </p:ext>
+    </p:extLst>
+  </p:cSld>
+  <p:clrMapOvr>
+    <a:masterClrMapping/>
+  </p:clrMapOvr>
+</p:sld>
+</file>
+
+<file path=ppt/slides/slide34.xml><?xml version="1.0" encoding="utf-8"?>
+<p:sld xmlns:a="http://schemas.openxmlformats.org/drawingml/2006/main" xmlns:r="http://schemas.openxmlformats.org/officeDocument/2006/relationships" xmlns:p="http://schemas.openxmlformats.org/presentationml/2006/main">
+  <p:cSld>
+    <p:spTree>
+      <p:nvGrpSpPr>
+        <p:cNvPr id="1" name="">
+          <a:extLst>
+            <a:ext uri="{FF2B5EF4-FFF2-40B4-BE49-F238E27FC236}">
+              <a16:creationId xmlns:a16="http://schemas.microsoft.com/office/drawing/2014/main" id="{A32EA070-AD8F-1B0E-B33F-20FEBB2B39B3}"/>
+            </a:ext>
+          </a:extLst>
+        </p:cNvPr>
+        <p:cNvGrpSpPr/>
+        <p:nvPr/>
+      </p:nvGrpSpPr>
+      <p:grpSpPr>
+        <a:xfrm>
+          <a:off x="0" y="0"/>
+          <a:ext cx="0" cy="0"/>
+          <a:chOff x="0" y="0"/>
+          <a:chExt cx="0" cy="0"/>
+        </a:xfrm>
+      </p:grpSpPr>
+      <p:pic>
+        <p:nvPicPr>
+          <p:cNvPr id="5" name="Picture 2">
+            <a:extLst>
+              <a:ext uri="{FF2B5EF4-FFF2-40B4-BE49-F238E27FC236}">
+                <a16:creationId xmlns:a16="http://schemas.microsoft.com/office/drawing/2014/main" id="{3DB73F6E-2D3E-AFFE-E838-25A499833C66}"/>
+              </a:ext>
+            </a:extLst>
+          </p:cNvPr>
+          <p:cNvPicPr>
+            <a:picLocks noChangeAspect="1" noChangeArrowheads="1"/>
+          </p:cNvPicPr>
+          <p:nvPr/>
+        </p:nvPicPr>
+        <p:blipFill rotWithShape="1">
+          <a:blip r:embed="rId3">
+            <a:extLst>
+              <a:ext uri="{28A0092B-C50C-407E-A947-70E740481C1C}">
+                <a14:useLocalDpi xmlns:a14="http://schemas.microsoft.com/office/drawing/2010/main" val="0"/>
+              </a:ext>
+            </a:extLst>
+          </a:blip>
+          <a:srcRect t="27013"/>
+          <a:stretch>
+            <a:fillRect/>
+          </a:stretch>
+        </p:blipFill>
+        <p:spPr bwMode="auto">
+          <a:xfrm>
+            <a:off x="1143000" y="1965960"/>
+            <a:ext cx="6576023" cy="4282440"/>
+          </a:xfrm>
+          <a:prstGeom prst="rect">
+            <a:avLst/>
+          </a:prstGeom>
+          <a:noFill/>
+          <a:ln>
+            <a:noFill/>
+          </a:ln>
+          <a:effectLst/>
+          <a:extLst>
+            <a:ext uri="{909E8E84-426E-40DD-AFC4-6F175D3DCCD1}">
+              <a14:hiddenFill xmlns:a14="http://schemas.microsoft.com/office/drawing/2010/main">
+                <a:solidFill>
+                  <a:schemeClr val="accent1"/>
+                </a:solidFill>
+              </a14:hiddenFill>
+            </a:ext>
+            <a:ext uri="{91240B29-F687-4F45-9708-019B960494DF}">
+              <a14:hiddenLine xmlns:a14="http://schemas.microsoft.com/office/drawing/2010/main" w="9525">
+                <a:solidFill>
+                  <a:schemeClr val="tx1"/>
+                </a:solidFill>
+                <a:miter lim="800000"/>
+                <a:headEnd/>
+                <a:tailEnd/>
+              </a14:hiddenLine>
+            </a:ext>
+            <a:ext uri="{AF507438-7753-43E0-B8FC-AC1667EBCBE1}">
+              <a14:hiddenEffects xmlns:a14="http://schemas.microsoft.com/office/drawing/2010/main">
+                <a:effectLst>
+                  <a:outerShdw dist="35921" dir="2700000" algn="ctr" rotWithShape="0">
+                    <a:schemeClr val="bg2"/>
+                  </a:outerShdw>
+                </a:effectLst>
+              </a14:hiddenEffects>
+            </a:ext>
+          </a:extLst>
+        </p:spPr>
+      </p:pic>
+      <p:sp>
+        <p:nvSpPr>
+          <p:cNvPr id="2" name="TextBox 1">
+            <a:extLst>
+              <a:ext uri="{FF2B5EF4-FFF2-40B4-BE49-F238E27FC236}">
+                <a16:creationId xmlns:a16="http://schemas.microsoft.com/office/drawing/2014/main" id="{30465165-FE0C-72FF-F27E-50040A3EEE09}"/>
+              </a:ext>
+            </a:extLst>
+          </p:cNvPr>
+          <p:cNvSpPr txBox="1"/>
+          <p:nvPr/>
+        </p:nvSpPr>
+        <p:spPr>
+          <a:xfrm>
+            <a:off x="4252682" y="5026285"/>
+            <a:ext cx="370614" cy="276999"/>
+          </a:xfrm>
+          <a:prstGeom prst="rect">
+            <a:avLst/>
+          </a:prstGeom>
+          <a:solidFill>
+            <a:schemeClr val="bg1"/>
+          </a:solidFill>
+        </p:spPr>
+        <p:txBody>
+          <a:bodyPr wrap="none" rtlCol="0">
+            <a:spAutoFit/>
+          </a:bodyPr>
+          <a:lstStyle/>
+          <a:p>
+            <a:r>
+              <a:rPr lang="en-US" sz="1200" dirty="0"/>
+              <a:t>d</a:t>
+            </a:r>
+            <a:r>
+              <a:rPr lang="en-US" sz="1200" baseline="-25000" dirty="0"/>
+              <a:t>o1</a:t>
+            </a:r>
+          </a:p>
+        </p:txBody>
+      </p:sp>
+      <p:sp>
+        <p:nvSpPr>
+          <p:cNvPr id="3" name="TextBox 2">
+            <a:extLst>
+              <a:ext uri="{FF2B5EF4-FFF2-40B4-BE49-F238E27FC236}">
+                <a16:creationId xmlns:a16="http://schemas.microsoft.com/office/drawing/2014/main" id="{32AF2C7C-30E9-1176-290E-A5DDED8026FB}"/>
+              </a:ext>
+            </a:extLst>
+          </p:cNvPr>
+          <p:cNvSpPr txBox="1"/>
+          <p:nvPr/>
+        </p:nvSpPr>
+        <p:spPr>
+          <a:xfrm>
+            <a:off x="5061319" y="5487724"/>
+            <a:ext cx="367408" cy="307777"/>
+          </a:xfrm>
+          <a:prstGeom prst="rect">
+            <a:avLst/>
+          </a:prstGeom>
+          <a:solidFill>
+            <a:schemeClr val="bg1"/>
+          </a:solidFill>
+        </p:spPr>
+        <p:txBody>
+          <a:bodyPr wrap="none" rtlCol="0">
+            <a:spAutoFit/>
+          </a:bodyPr>
+          <a:lstStyle/>
+          <a:p>
+            <a:r>
+              <a:rPr lang="en-US" sz="1400"/>
+              <a:t>d</a:t>
+            </a:r>
+            <a:r>
+              <a:rPr lang="en-US" sz="1400" baseline="-25000"/>
+              <a:t>i1</a:t>
+            </a:r>
+            <a:endParaRPr lang="en-US" sz="1400" baseline="-25000" dirty="0"/>
+          </a:p>
+        </p:txBody>
+      </p:sp>
+      <p:sp>
+        <p:nvSpPr>
+          <p:cNvPr id="7" name="TextBox 6">
+            <a:extLst>
+              <a:ext uri="{FF2B5EF4-FFF2-40B4-BE49-F238E27FC236}">
+                <a16:creationId xmlns:a16="http://schemas.microsoft.com/office/drawing/2014/main" id="{14565300-E9C2-6A20-FE6C-8CD267E127F2}"/>
+              </a:ext>
+            </a:extLst>
+          </p:cNvPr>
+          <p:cNvSpPr txBox="1"/>
+          <p:nvPr/>
+        </p:nvSpPr>
+        <p:spPr>
+          <a:xfrm>
+            <a:off x="7262438" y="3167390"/>
+            <a:ext cx="550151" cy="523220"/>
+          </a:xfrm>
+          <a:prstGeom prst="rect">
+            <a:avLst/>
+          </a:prstGeom>
+          <a:solidFill>
+            <a:schemeClr val="bg1"/>
+          </a:solidFill>
+        </p:spPr>
+        <p:txBody>
+          <a:bodyPr wrap="none" rtlCol="0">
+            <a:spAutoFit/>
+          </a:bodyPr>
+          <a:lstStyle/>
+          <a:p>
+            <a:r>
+              <a:rPr lang="en-US" sz="2800" dirty="0"/>
+              <a:t>h</a:t>
+            </a:r>
+            <a:r>
+              <a:rPr lang="en-US" sz="2800" baseline="-25000" dirty="0"/>
+              <a:t>i1</a:t>
+            </a:r>
+          </a:p>
+        </p:txBody>
+      </p:sp>
+      <p:sp>
+        <p:nvSpPr>
+          <p:cNvPr id="9" name="TextBox 8">
+            <a:extLst>
+              <a:ext uri="{FF2B5EF4-FFF2-40B4-BE49-F238E27FC236}">
+                <a16:creationId xmlns:a16="http://schemas.microsoft.com/office/drawing/2014/main" id="{86C17D14-3B66-C55C-75BA-866F61060409}"/>
+              </a:ext>
+            </a:extLst>
+          </p:cNvPr>
+          <p:cNvSpPr txBox="1"/>
+          <p:nvPr/>
+        </p:nvSpPr>
+        <p:spPr>
+          <a:xfrm>
+            <a:off x="5547398" y="3409676"/>
+            <a:ext cx="388248" cy="369332"/>
+          </a:xfrm>
+          <a:prstGeom prst="rect">
+            <a:avLst/>
+          </a:prstGeom>
+          <a:solidFill>
+            <a:schemeClr val="bg1"/>
+          </a:solidFill>
+        </p:spPr>
+        <p:txBody>
+          <a:bodyPr wrap="none" rtlCol="0">
+            <a:spAutoFit/>
+          </a:bodyPr>
+          <a:lstStyle/>
+          <a:p>
+            <a:r>
+              <a:rPr lang="en-US" dirty="0"/>
+              <a:t>h</a:t>
+            </a:r>
+            <a:r>
+              <a:rPr lang="en-US" baseline="-25000" dirty="0"/>
+              <a:t>o</a:t>
+            </a:r>
+          </a:p>
+        </p:txBody>
+      </p:sp>
+      <p:sp>
+        <p:nvSpPr>
+          <p:cNvPr id="14" name="TextBox 13">
+            <a:extLst>
+              <a:ext uri="{FF2B5EF4-FFF2-40B4-BE49-F238E27FC236}">
+                <a16:creationId xmlns:a16="http://schemas.microsoft.com/office/drawing/2014/main" id="{3BC26C1A-5C69-4D2D-5568-286A3EC771C3}"/>
+              </a:ext>
+            </a:extLst>
+          </p:cNvPr>
+          <p:cNvSpPr txBox="1"/>
+          <p:nvPr/>
+        </p:nvSpPr>
+        <p:spPr>
+          <a:xfrm>
+            <a:off x="3399332" y="3731342"/>
+            <a:ext cx="216726" cy="261610"/>
+          </a:xfrm>
+          <a:prstGeom prst="rect">
+            <a:avLst/>
+          </a:prstGeom>
+          <a:noFill/>
+        </p:spPr>
+        <p:txBody>
+          <a:bodyPr wrap="none" rtlCol="0">
+            <a:spAutoFit/>
+          </a:bodyPr>
+          <a:lstStyle/>
+          <a:p>
+            <a:r>
+              <a:rPr lang="en-US" sz="1100" dirty="0"/>
+              <a:t>i</a:t>
+            </a:r>
+          </a:p>
+        </p:txBody>
+      </p:sp>
+      <p:sp>
+        <p:nvSpPr>
+          <p:cNvPr id="4" name="TextBox 3">
+            <a:extLst>
+              <a:ext uri="{FF2B5EF4-FFF2-40B4-BE49-F238E27FC236}">
+                <a16:creationId xmlns:a16="http://schemas.microsoft.com/office/drawing/2014/main" id="{06E94AA0-024C-32DE-81DE-D8807A41EFB3}"/>
+              </a:ext>
+            </a:extLst>
+          </p:cNvPr>
+          <p:cNvSpPr txBox="1"/>
+          <p:nvPr/>
+        </p:nvSpPr>
+        <p:spPr>
+          <a:xfrm>
+            <a:off x="2284022" y="3942431"/>
+            <a:ext cx="216726" cy="261610"/>
+          </a:xfrm>
+          <a:prstGeom prst="rect">
+            <a:avLst/>
+          </a:prstGeom>
+          <a:noFill/>
+        </p:spPr>
+        <p:txBody>
+          <a:bodyPr wrap="none" rtlCol="0">
+            <a:spAutoFit/>
+          </a:bodyPr>
+          <a:lstStyle/>
+          <a:p>
+            <a:r>
+              <a:rPr lang="en-US" sz="1100" dirty="0"/>
+              <a:t>i</a:t>
+            </a:r>
+          </a:p>
+        </p:txBody>
+      </p:sp>
+      <p:sp>
+        <p:nvSpPr>
+          <p:cNvPr id="12" name="Rectangle 11">
+            <a:extLst>
+              <a:ext uri="{FF2B5EF4-FFF2-40B4-BE49-F238E27FC236}">
+                <a16:creationId xmlns:a16="http://schemas.microsoft.com/office/drawing/2014/main" id="{7A60A404-5F26-A6AB-FA92-97262AE6C916}"/>
+              </a:ext>
+            </a:extLst>
+          </p:cNvPr>
+          <p:cNvSpPr/>
+          <p:nvPr/>
+        </p:nvSpPr>
+        <p:spPr>
+          <a:xfrm>
+            <a:off x="2500748" y="5816103"/>
+            <a:ext cx="4530983" cy="745651"/>
+          </a:xfrm>
+          <a:prstGeom prst="rect">
+            <a:avLst/>
+          </a:prstGeom>
+          <a:solidFill>
+            <a:schemeClr val="bg1"/>
+          </a:solidFill>
+          <a:ln>
+            <a:noFill/>
+          </a:ln>
+        </p:spPr>
+        <p:style>
+          <a:lnRef idx="2">
+            <a:schemeClr val="accent1">
+              <a:shade val="15000"/>
+            </a:schemeClr>
+          </a:lnRef>
+          <a:fillRef idx="1">
+            <a:schemeClr val="accent1"/>
+          </a:fillRef>
+          <a:effectRef idx="0">
+            <a:schemeClr val="accent1"/>
+          </a:effectRef>
+          <a:fontRef idx="minor">
+            <a:schemeClr val="lt1"/>
+          </a:fontRef>
+        </p:style>
+        <p:txBody>
+          <a:bodyPr rtlCol="0" anchor="ctr"/>
+          <a:lstStyle/>
+          <a:p>
+            <a:pPr algn="ctr"/>
+            <a:endParaRPr lang="en-US"/>
+          </a:p>
+        </p:txBody>
+      </p:sp>
+      <p:cxnSp>
+        <p:nvCxnSpPr>
+          <p:cNvPr id="16" name="Straight Connector 15">
+            <a:extLst>
+              <a:ext uri="{FF2B5EF4-FFF2-40B4-BE49-F238E27FC236}">
+                <a16:creationId xmlns:a16="http://schemas.microsoft.com/office/drawing/2014/main" id="{AF4B9E8A-D3D0-393B-0F3B-42C9C3E877D8}"/>
+              </a:ext>
+            </a:extLst>
+          </p:cNvPr>
+          <p:cNvCxnSpPr>
+            <a:cxnSpLocks/>
+          </p:cNvCxnSpPr>
+          <p:nvPr/>
+        </p:nvCxnSpPr>
+        <p:spPr>
+          <a:xfrm>
+            <a:off x="6550614" y="5559552"/>
+            <a:ext cx="0" cy="576939"/>
+          </a:xfrm>
+          <a:prstGeom prst="line">
+            <a:avLst/>
+          </a:prstGeom>
+          <a:ln>
+            <a:solidFill>
+              <a:schemeClr val="tx1"/>
+            </a:solidFill>
+            <a:prstDash val="dash"/>
+          </a:ln>
+        </p:spPr>
+        <p:style>
+          <a:lnRef idx="1">
+            <a:schemeClr val="accent1"/>
+          </a:lnRef>
+          <a:fillRef idx="0">
+            <a:schemeClr val="accent1"/>
+          </a:fillRef>
+          <a:effectRef idx="0">
+            <a:schemeClr val="accent1"/>
+          </a:effectRef>
+          <a:fontRef idx="minor">
+            <a:schemeClr val="tx1"/>
+          </a:fontRef>
+        </p:style>
+      </p:cxnSp>
+      <p:cxnSp>
+        <p:nvCxnSpPr>
+          <p:cNvPr id="10" name="Straight Connector 9">
+            <a:extLst>
+              <a:ext uri="{FF2B5EF4-FFF2-40B4-BE49-F238E27FC236}">
+                <a16:creationId xmlns:a16="http://schemas.microsoft.com/office/drawing/2014/main" id="{F844211F-6B62-2DF3-155B-F8B55F40E33A}"/>
+              </a:ext>
+            </a:extLst>
+          </p:cNvPr>
+          <p:cNvCxnSpPr>
+            <a:cxnSpLocks/>
+          </p:cNvCxnSpPr>
+          <p:nvPr/>
+        </p:nvCxnSpPr>
+        <p:spPr>
+          <a:xfrm>
+            <a:off x="2941782" y="3862147"/>
+            <a:ext cx="0" cy="2386253"/>
+          </a:xfrm>
+          <a:prstGeom prst="line">
+            <a:avLst/>
+          </a:prstGeom>
+          <a:ln>
+            <a:solidFill>
+              <a:schemeClr val="tx1"/>
+            </a:solidFill>
+            <a:prstDash val="dash"/>
+          </a:ln>
+        </p:spPr>
+        <p:style>
+          <a:lnRef idx="1">
+            <a:schemeClr val="accent1"/>
+          </a:lnRef>
+          <a:fillRef idx="0">
+            <a:schemeClr val="accent1"/>
+          </a:fillRef>
+          <a:effectRef idx="0">
+            <a:schemeClr val="accent1"/>
+          </a:effectRef>
+          <a:fontRef idx="minor">
+            <a:schemeClr val="tx1"/>
+          </a:fontRef>
+        </p:style>
+      </p:cxnSp>
+      <p:cxnSp>
+        <p:nvCxnSpPr>
+          <p:cNvPr id="21" name="Straight Arrow Connector 20">
+            <a:extLst>
+              <a:ext uri="{FF2B5EF4-FFF2-40B4-BE49-F238E27FC236}">
+                <a16:creationId xmlns:a16="http://schemas.microsoft.com/office/drawing/2014/main" id="{70E7C15F-4CD4-9C43-BD1D-D907E35AD5D9}"/>
+              </a:ext>
+            </a:extLst>
+          </p:cNvPr>
+          <p:cNvCxnSpPr/>
+          <p:nvPr/>
+        </p:nvCxnSpPr>
+        <p:spPr>
+          <a:xfrm>
+            <a:off x="2941782" y="5985181"/>
+            <a:ext cx="3608832" cy="0"/>
+          </a:xfrm>
+          <a:prstGeom prst="straightConnector1">
+            <a:avLst/>
+          </a:prstGeom>
+          <a:ln w="28575">
+            <a:solidFill>
+              <a:schemeClr val="tx1"/>
+            </a:solidFill>
+            <a:headEnd type="triangle"/>
+            <a:tailEnd type="triangle"/>
+          </a:ln>
+        </p:spPr>
+        <p:style>
+          <a:lnRef idx="1">
+            <a:schemeClr val="accent1"/>
+          </a:lnRef>
+          <a:fillRef idx="0">
+            <a:schemeClr val="accent1"/>
+          </a:fillRef>
+          <a:effectRef idx="0">
+            <a:schemeClr val="accent1"/>
+          </a:effectRef>
+          <a:fontRef idx="minor">
+            <a:schemeClr val="tx1"/>
+          </a:fontRef>
+        </p:style>
+      </p:cxnSp>
+      <p:sp>
+        <p:nvSpPr>
+          <p:cNvPr id="22" name="TextBox 21">
+            <a:extLst>
+              <a:ext uri="{FF2B5EF4-FFF2-40B4-BE49-F238E27FC236}">
+                <a16:creationId xmlns:a16="http://schemas.microsoft.com/office/drawing/2014/main" id="{FF579F81-C611-AF56-9E16-81264727CD9E}"/>
+              </a:ext>
+            </a:extLst>
+          </p:cNvPr>
+          <p:cNvSpPr txBox="1"/>
+          <p:nvPr/>
+        </p:nvSpPr>
+        <p:spPr>
+          <a:xfrm>
+            <a:off x="4625014" y="5816103"/>
+            <a:ext cx="282450" cy="369332"/>
+          </a:xfrm>
+          <a:prstGeom prst="rect">
+            <a:avLst/>
+          </a:prstGeom>
+          <a:solidFill>
+            <a:schemeClr val="bg1"/>
+          </a:solidFill>
+        </p:spPr>
+        <p:txBody>
+          <a:bodyPr wrap="none" rtlCol="0">
+            <a:spAutoFit/>
+          </a:bodyPr>
+          <a:lstStyle/>
+          <a:p>
+            <a:r>
+              <a:rPr lang="en-US" dirty="0"/>
+              <a:t>L</a:t>
+            </a:r>
+          </a:p>
+        </p:txBody>
+      </p:sp>
+      <p:cxnSp>
+        <p:nvCxnSpPr>
+          <p:cNvPr id="23" name="Straight Arrow Connector 22">
+            <a:extLst>
+              <a:ext uri="{FF2B5EF4-FFF2-40B4-BE49-F238E27FC236}">
+                <a16:creationId xmlns:a16="http://schemas.microsoft.com/office/drawing/2014/main" id="{3E42D5FE-1662-1927-3CF2-EC86929AF629}"/>
+              </a:ext>
+            </a:extLst>
+          </p:cNvPr>
+          <p:cNvCxnSpPr>
+            <a:cxnSpLocks/>
+          </p:cNvCxnSpPr>
+          <p:nvPr/>
+        </p:nvCxnSpPr>
+        <p:spPr>
+          <a:xfrm>
+            <a:off x="2941782" y="5471157"/>
+            <a:ext cx="889554" cy="0"/>
+          </a:xfrm>
+          <a:prstGeom prst="straightConnector1">
+            <a:avLst/>
+          </a:prstGeom>
+          <a:ln w="12700">
+            <a:solidFill>
+              <a:schemeClr val="tx1"/>
+            </a:solidFill>
+            <a:headEnd type="triangle"/>
+            <a:tailEnd type="triangle"/>
+          </a:ln>
+        </p:spPr>
+        <p:style>
+          <a:lnRef idx="1">
+            <a:schemeClr val="accent1"/>
+          </a:lnRef>
+          <a:fillRef idx="0">
+            <a:schemeClr val="accent1"/>
+          </a:fillRef>
+          <a:effectRef idx="0">
+            <a:schemeClr val="accent1"/>
+          </a:effectRef>
+          <a:fontRef idx="minor">
+            <a:schemeClr val="tx1"/>
+          </a:fontRef>
+        </p:style>
+      </p:cxnSp>
+      <p:sp>
+        <p:nvSpPr>
+          <p:cNvPr id="25" name="TextBox 24">
+            <a:extLst>
+              <a:ext uri="{FF2B5EF4-FFF2-40B4-BE49-F238E27FC236}">
+                <a16:creationId xmlns:a16="http://schemas.microsoft.com/office/drawing/2014/main" id="{2BEE2BAD-9820-2BD8-B7AC-ADC9829791B3}"/>
+              </a:ext>
+            </a:extLst>
+          </p:cNvPr>
+          <p:cNvSpPr txBox="1"/>
+          <p:nvPr/>
+        </p:nvSpPr>
+        <p:spPr>
+          <a:xfrm>
+            <a:off x="3247687" y="5318083"/>
+            <a:ext cx="260008" cy="369332"/>
+          </a:xfrm>
+          <a:prstGeom prst="rect">
+            <a:avLst/>
+          </a:prstGeom>
+          <a:solidFill>
+            <a:schemeClr val="bg1"/>
+          </a:solidFill>
+        </p:spPr>
+        <p:txBody>
+          <a:bodyPr wrap="none" rtlCol="0">
+            <a:spAutoFit/>
+          </a:bodyPr>
+          <a:lstStyle/>
+          <a:p>
+            <a:r>
+              <a:rPr lang="en-US" dirty="0">
+                <a:latin typeface="Script MT Bold" panose="03040602040607080904" pitchFamily="66" charset="0"/>
+              </a:rPr>
+              <a:t>l</a:t>
+            </a:r>
+            <a:endParaRPr lang="en-US" dirty="0"/>
+          </a:p>
+        </p:txBody>
+      </p:sp>
+      <p:sp>
+        <p:nvSpPr>
+          <p:cNvPr id="6" name="TextBox 5">
+            <a:extLst>
+              <a:ext uri="{FF2B5EF4-FFF2-40B4-BE49-F238E27FC236}">
+                <a16:creationId xmlns:a16="http://schemas.microsoft.com/office/drawing/2014/main" id="{78DBAE7E-2531-3CDB-CD71-CDD4992E9972}"/>
+              </a:ext>
+            </a:extLst>
+          </p:cNvPr>
+          <p:cNvSpPr txBox="1"/>
+          <p:nvPr/>
+        </p:nvSpPr>
+        <p:spPr>
+          <a:xfrm>
+            <a:off x="1048396" y="4019375"/>
+            <a:ext cx="667511" cy="369332"/>
+          </a:xfrm>
+          <a:prstGeom prst="rect">
+            <a:avLst/>
+          </a:prstGeom>
+          <a:solidFill>
+            <a:schemeClr val="bg1"/>
+          </a:solidFill>
+        </p:spPr>
+        <p:txBody>
+          <a:bodyPr wrap="square" rtlCol="0">
+            <a:spAutoFit/>
+          </a:bodyPr>
+          <a:lstStyle/>
+          <a:p>
+            <a:r>
+              <a:rPr lang="en-US" dirty="0"/>
+              <a:t>    h</a:t>
+            </a:r>
+            <a:r>
+              <a:rPr lang="en-US" baseline="-25000" dirty="0"/>
+              <a:t>i2</a:t>
+            </a:r>
+          </a:p>
+        </p:txBody>
+      </p:sp>
+      <p:pic>
+        <p:nvPicPr>
+          <p:cNvPr id="8" name="Graphic 7">
+            <a:extLst>
+              <a:ext uri="{FF2B5EF4-FFF2-40B4-BE49-F238E27FC236}">
+                <a16:creationId xmlns:a16="http://schemas.microsoft.com/office/drawing/2014/main" id="{3FA4C704-C712-2354-C670-D1048D1F5780}"/>
+              </a:ext>
+            </a:extLst>
+          </p:cNvPr>
+          <p:cNvPicPr>
+            <a:picLocks noChangeAspect="1"/>
+          </p:cNvPicPr>
+          <p:nvPr/>
+        </p:nvPicPr>
+        <p:blipFill>
+          <a:blip>
+            <a:extLst>
+              <a:ext uri="{96DAC541-7B7A-43D3-8B79-37D633B846F1}">
+                <asvg:svgBlip xmlns:asvg="http://schemas.microsoft.com/office/drawing/2016/SVG/main" r:embed="rId4"/>
+              </a:ext>
+            </a:extLst>
+          </a:blip>
+          <a:srcRect b="73540"/>
+          <a:stretch>
+            <a:fillRect/>
+          </a:stretch>
+        </p:blipFill>
+        <p:spPr>
+          <a:xfrm>
+            <a:off x="1048396" y="-105101"/>
+            <a:ext cx="7294936" cy="1814651"/>
+          </a:xfrm>
+          <a:prstGeom prst="rect">
+            <a:avLst/>
+          </a:prstGeom>
+        </p:spPr>
+      </p:pic>
+    </p:spTree>
+    <p:extLst>
+      <p:ext uri="{BB962C8B-B14F-4D97-AF65-F5344CB8AC3E}">
+        <p14:creationId xmlns:p14="http://schemas.microsoft.com/office/powerpoint/2010/main" val="855844419"/>
+      </p:ext>
+    </p:extLst>
+  </p:cSld>
+  <p:clrMapOvr>
+    <a:masterClrMapping/>
+  </p:clrMapOvr>
+</p:sld>
+</file>
+
+<file path=ppt/slides/slide35.xml><?xml version="1.0" encoding="utf-8"?>
 <p:sld xmlns:a="http://schemas.openxmlformats.org/drawingml/2006/main" xmlns:r="http://schemas.openxmlformats.org/officeDocument/2006/relationships" xmlns:p="http://schemas.openxmlformats.org/presentationml/2006/main">
   <p:cSld>
     <p:spTree>
@@ -10173,735 +11413,7 @@
 </p:sld>
 </file>
 
-<file path=ppt/slides/slide31.xml><?xml version="1.0" encoding="utf-8"?>
-<p:sld xmlns:a="http://schemas.openxmlformats.org/drawingml/2006/main" xmlns:r="http://schemas.openxmlformats.org/officeDocument/2006/relationships" xmlns:p="http://schemas.openxmlformats.org/presentationml/2006/main">
-  <p:cSld>
-    <p:spTree>
-      <p:nvGrpSpPr>
-        <p:cNvPr id="1" name="">
-          <a:extLst>
-            <a:ext uri="{FF2B5EF4-FFF2-40B4-BE49-F238E27FC236}">
-              <a16:creationId xmlns:a16="http://schemas.microsoft.com/office/drawing/2014/main" id="{A32EA070-AD8F-1B0E-B33F-20FEBB2B39B3}"/>
-            </a:ext>
-          </a:extLst>
-        </p:cNvPr>
-        <p:cNvGrpSpPr/>
-        <p:nvPr/>
-      </p:nvGrpSpPr>
-      <p:grpSpPr>
-        <a:xfrm>
-          <a:off x="0" y="0"/>
-          <a:ext cx="0" cy="0"/>
-          <a:chOff x="0" y="0"/>
-          <a:chExt cx="0" cy="0"/>
-        </a:xfrm>
-      </p:grpSpPr>
-      <p:pic>
-        <p:nvPicPr>
-          <p:cNvPr id="5" name="Picture 2">
-            <a:extLst>
-              <a:ext uri="{FF2B5EF4-FFF2-40B4-BE49-F238E27FC236}">
-                <a16:creationId xmlns:a16="http://schemas.microsoft.com/office/drawing/2014/main" id="{3DB73F6E-2D3E-AFFE-E838-25A499833C66}"/>
-              </a:ext>
-            </a:extLst>
-          </p:cNvPr>
-          <p:cNvPicPr>
-            <a:picLocks noChangeAspect="1" noChangeArrowheads="1"/>
-          </p:cNvPicPr>
-          <p:nvPr/>
-        </p:nvPicPr>
-        <p:blipFill rotWithShape="1">
-          <a:blip r:embed="rId3">
-            <a:extLst>
-              <a:ext uri="{28A0092B-C50C-407E-A947-70E740481C1C}">
-                <a14:useLocalDpi xmlns:a14="http://schemas.microsoft.com/office/drawing/2010/main" val="0"/>
-              </a:ext>
-            </a:extLst>
-          </a:blip>
-          <a:srcRect t="27013"/>
-          <a:stretch>
-            <a:fillRect/>
-          </a:stretch>
-        </p:blipFill>
-        <p:spPr bwMode="auto">
-          <a:xfrm>
-            <a:off x="1143000" y="1965960"/>
-            <a:ext cx="6576023" cy="4282440"/>
-          </a:xfrm>
-          <a:prstGeom prst="rect">
-            <a:avLst/>
-          </a:prstGeom>
-          <a:noFill/>
-          <a:ln>
-            <a:noFill/>
-          </a:ln>
-          <a:effectLst/>
-          <a:extLst>
-            <a:ext uri="{909E8E84-426E-40DD-AFC4-6F175D3DCCD1}">
-              <a14:hiddenFill xmlns:a14="http://schemas.microsoft.com/office/drawing/2010/main">
-                <a:solidFill>
-                  <a:schemeClr val="accent1"/>
-                </a:solidFill>
-              </a14:hiddenFill>
-            </a:ext>
-            <a:ext uri="{91240B29-F687-4F45-9708-019B960494DF}">
-              <a14:hiddenLine xmlns:a14="http://schemas.microsoft.com/office/drawing/2010/main" w="9525">
-                <a:solidFill>
-                  <a:schemeClr val="tx1"/>
-                </a:solidFill>
-                <a:miter lim="800000"/>
-                <a:headEnd/>
-                <a:tailEnd/>
-              </a14:hiddenLine>
-            </a:ext>
-            <a:ext uri="{AF507438-7753-43E0-B8FC-AC1667EBCBE1}">
-              <a14:hiddenEffects xmlns:a14="http://schemas.microsoft.com/office/drawing/2010/main">
-                <a:effectLst>
-                  <a:outerShdw dist="35921" dir="2700000" algn="ctr" rotWithShape="0">
-                    <a:schemeClr val="bg2"/>
-                  </a:outerShdw>
-                </a:effectLst>
-              </a14:hiddenEffects>
-            </a:ext>
-          </a:extLst>
-        </p:spPr>
-      </p:pic>
-      <p:sp>
-        <p:nvSpPr>
-          <p:cNvPr id="2" name="TextBox 1">
-            <a:extLst>
-              <a:ext uri="{FF2B5EF4-FFF2-40B4-BE49-F238E27FC236}">
-                <a16:creationId xmlns:a16="http://schemas.microsoft.com/office/drawing/2014/main" id="{30465165-FE0C-72FF-F27E-50040A3EEE09}"/>
-              </a:ext>
-            </a:extLst>
-          </p:cNvPr>
-          <p:cNvSpPr txBox="1"/>
-          <p:nvPr/>
-        </p:nvSpPr>
-        <p:spPr>
-          <a:xfrm>
-            <a:off x="4252682" y="5026285"/>
-            <a:ext cx="319318" cy="276999"/>
-          </a:xfrm>
-          <a:prstGeom prst="rect">
-            <a:avLst/>
-          </a:prstGeom>
-          <a:solidFill>
-            <a:schemeClr val="bg1"/>
-          </a:solidFill>
-        </p:spPr>
-        <p:txBody>
-          <a:bodyPr wrap="none" rtlCol="0">
-            <a:spAutoFit/>
-          </a:bodyPr>
-          <a:lstStyle/>
-          <a:p>
-            <a:r>
-              <a:rPr lang="en-US" sz="1200" dirty="0"/>
-              <a:t>d</a:t>
-            </a:r>
-            <a:r>
-              <a:rPr lang="en-US" sz="1200" baseline="-25000" dirty="0"/>
-              <a:t>o</a:t>
-            </a:r>
-          </a:p>
-        </p:txBody>
-      </p:sp>
-      <p:sp>
-        <p:nvSpPr>
-          <p:cNvPr id="3" name="TextBox 2">
-            <a:extLst>
-              <a:ext uri="{FF2B5EF4-FFF2-40B4-BE49-F238E27FC236}">
-                <a16:creationId xmlns:a16="http://schemas.microsoft.com/office/drawing/2014/main" id="{32AF2C7C-30E9-1176-290E-A5DDED8026FB}"/>
-              </a:ext>
-            </a:extLst>
-          </p:cNvPr>
-          <p:cNvSpPr txBox="1"/>
-          <p:nvPr/>
-        </p:nvSpPr>
-        <p:spPr>
-          <a:xfrm>
-            <a:off x="5061319" y="5487724"/>
-            <a:ext cx="306494" cy="307777"/>
-          </a:xfrm>
-          <a:prstGeom prst="rect">
-            <a:avLst/>
-          </a:prstGeom>
-          <a:solidFill>
-            <a:schemeClr val="bg1"/>
-          </a:solidFill>
-        </p:spPr>
-        <p:txBody>
-          <a:bodyPr wrap="none" rtlCol="0">
-            <a:spAutoFit/>
-          </a:bodyPr>
-          <a:lstStyle/>
-          <a:p>
-            <a:r>
-              <a:rPr lang="en-US" sz="1400" dirty="0"/>
-              <a:t>d</a:t>
-            </a:r>
-            <a:r>
-              <a:rPr lang="en-US" sz="1400" baseline="-25000" dirty="0"/>
-              <a:t>i</a:t>
-            </a:r>
-          </a:p>
-        </p:txBody>
-      </p:sp>
-      <p:sp>
-        <p:nvSpPr>
-          <p:cNvPr id="7" name="TextBox 6">
-            <a:extLst>
-              <a:ext uri="{FF2B5EF4-FFF2-40B4-BE49-F238E27FC236}">
-                <a16:creationId xmlns:a16="http://schemas.microsoft.com/office/drawing/2014/main" id="{14565300-E9C2-6A20-FE6C-8CD267E127F2}"/>
-              </a:ext>
-            </a:extLst>
-          </p:cNvPr>
-          <p:cNvSpPr txBox="1"/>
-          <p:nvPr/>
-        </p:nvSpPr>
-        <p:spPr>
-          <a:xfrm>
-            <a:off x="7262438" y="3167390"/>
-            <a:ext cx="428322" cy="523220"/>
-          </a:xfrm>
-          <a:prstGeom prst="rect">
-            <a:avLst/>
-          </a:prstGeom>
-          <a:solidFill>
-            <a:schemeClr val="bg1"/>
-          </a:solidFill>
-        </p:spPr>
-        <p:txBody>
-          <a:bodyPr wrap="none" rtlCol="0">
-            <a:spAutoFit/>
-          </a:bodyPr>
-          <a:lstStyle/>
-          <a:p>
-            <a:r>
-              <a:rPr lang="en-US" sz="2800" dirty="0"/>
-              <a:t>h</a:t>
-            </a:r>
-            <a:r>
-              <a:rPr lang="en-US" sz="2800" baseline="-25000" dirty="0"/>
-              <a:t>i</a:t>
-            </a:r>
-          </a:p>
-        </p:txBody>
-      </p:sp>
-      <p:sp>
-        <p:nvSpPr>
-          <p:cNvPr id="9" name="TextBox 8">
-            <a:extLst>
-              <a:ext uri="{FF2B5EF4-FFF2-40B4-BE49-F238E27FC236}">
-                <a16:creationId xmlns:a16="http://schemas.microsoft.com/office/drawing/2014/main" id="{86C17D14-3B66-C55C-75BA-866F61060409}"/>
-              </a:ext>
-            </a:extLst>
-          </p:cNvPr>
-          <p:cNvSpPr txBox="1"/>
-          <p:nvPr/>
-        </p:nvSpPr>
-        <p:spPr>
-          <a:xfrm>
-            <a:off x="5547398" y="3409676"/>
-            <a:ext cx="388248" cy="369332"/>
-          </a:xfrm>
-          <a:prstGeom prst="rect">
-            <a:avLst/>
-          </a:prstGeom>
-          <a:solidFill>
-            <a:schemeClr val="bg1"/>
-          </a:solidFill>
-        </p:spPr>
-        <p:txBody>
-          <a:bodyPr wrap="none" rtlCol="0">
-            <a:spAutoFit/>
-          </a:bodyPr>
-          <a:lstStyle/>
-          <a:p>
-            <a:r>
-              <a:rPr lang="en-US" dirty="0"/>
-              <a:t>h</a:t>
-            </a:r>
-            <a:r>
-              <a:rPr lang="en-US" baseline="-25000" dirty="0"/>
-              <a:t>o</a:t>
-            </a:r>
-          </a:p>
-        </p:txBody>
-      </p:sp>
-      <p:sp>
-        <p:nvSpPr>
-          <p:cNvPr id="14" name="TextBox 13">
-            <a:extLst>
-              <a:ext uri="{FF2B5EF4-FFF2-40B4-BE49-F238E27FC236}">
-                <a16:creationId xmlns:a16="http://schemas.microsoft.com/office/drawing/2014/main" id="{3BC26C1A-5C69-4D2D-5568-286A3EC771C3}"/>
-              </a:ext>
-            </a:extLst>
-          </p:cNvPr>
-          <p:cNvSpPr txBox="1"/>
-          <p:nvPr/>
-        </p:nvSpPr>
-        <p:spPr>
-          <a:xfrm>
-            <a:off x="3399332" y="3731342"/>
-            <a:ext cx="216726" cy="261610"/>
-          </a:xfrm>
-          <a:prstGeom prst="rect">
-            <a:avLst/>
-          </a:prstGeom>
-          <a:noFill/>
-        </p:spPr>
-        <p:txBody>
-          <a:bodyPr wrap="none" rtlCol="0">
-            <a:spAutoFit/>
-          </a:bodyPr>
-          <a:lstStyle/>
-          <a:p>
-            <a:r>
-              <a:rPr lang="en-US" sz="1100" dirty="0"/>
-              <a:t>i</a:t>
-            </a:r>
-          </a:p>
-        </p:txBody>
-      </p:sp>
-      <p:sp>
-        <p:nvSpPr>
-          <p:cNvPr id="4" name="TextBox 3">
-            <a:extLst>
-              <a:ext uri="{FF2B5EF4-FFF2-40B4-BE49-F238E27FC236}">
-                <a16:creationId xmlns:a16="http://schemas.microsoft.com/office/drawing/2014/main" id="{06E94AA0-024C-32DE-81DE-D8807A41EFB3}"/>
-              </a:ext>
-            </a:extLst>
-          </p:cNvPr>
-          <p:cNvSpPr txBox="1"/>
-          <p:nvPr/>
-        </p:nvSpPr>
-        <p:spPr>
-          <a:xfrm>
-            <a:off x="2284022" y="3942431"/>
-            <a:ext cx="216726" cy="261610"/>
-          </a:xfrm>
-          <a:prstGeom prst="rect">
-            <a:avLst/>
-          </a:prstGeom>
-          <a:noFill/>
-        </p:spPr>
-        <p:txBody>
-          <a:bodyPr wrap="none" rtlCol="0">
-            <a:spAutoFit/>
-          </a:bodyPr>
-          <a:lstStyle/>
-          <a:p>
-            <a:r>
-              <a:rPr lang="en-US" sz="1100" dirty="0"/>
-              <a:t>i</a:t>
-            </a:r>
-          </a:p>
-        </p:txBody>
-      </p:sp>
-      <p:sp>
-        <p:nvSpPr>
-          <p:cNvPr id="12" name="Rectangle 11">
-            <a:extLst>
-              <a:ext uri="{FF2B5EF4-FFF2-40B4-BE49-F238E27FC236}">
-                <a16:creationId xmlns:a16="http://schemas.microsoft.com/office/drawing/2014/main" id="{7A60A404-5F26-A6AB-FA92-97262AE6C916}"/>
-              </a:ext>
-            </a:extLst>
-          </p:cNvPr>
-          <p:cNvSpPr/>
-          <p:nvPr/>
-        </p:nvSpPr>
-        <p:spPr>
-          <a:xfrm>
-            <a:off x="2500748" y="5816103"/>
-            <a:ext cx="4530983" cy="745651"/>
-          </a:xfrm>
-          <a:prstGeom prst="rect">
-            <a:avLst/>
-          </a:prstGeom>
-          <a:solidFill>
-            <a:schemeClr val="bg1"/>
-          </a:solidFill>
-          <a:ln>
-            <a:noFill/>
-          </a:ln>
-        </p:spPr>
-        <p:style>
-          <a:lnRef idx="2">
-            <a:schemeClr val="accent1">
-              <a:shade val="15000"/>
-            </a:schemeClr>
-          </a:lnRef>
-          <a:fillRef idx="1">
-            <a:schemeClr val="accent1"/>
-          </a:fillRef>
-          <a:effectRef idx="0">
-            <a:schemeClr val="accent1"/>
-          </a:effectRef>
-          <a:fontRef idx="minor">
-            <a:schemeClr val="lt1"/>
-          </a:fontRef>
-        </p:style>
-        <p:txBody>
-          <a:bodyPr rtlCol="0" anchor="ctr"/>
-          <a:lstStyle/>
-          <a:p>
-            <a:pPr algn="ctr"/>
-            <a:endParaRPr lang="en-US"/>
-          </a:p>
-        </p:txBody>
-      </p:sp>
-      <p:cxnSp>
-        <p:nvCxnSpPr>
-          <p:cNvPr id="16" name="Straight Connector 15">
-            <a:extLst>
-              <a:ext uri="{FF2B5EF4-FFF2-40B4-BE49-F238E27FC236}">
-                <a16:creationId xmlns:a16="http://schemas.microsoft.com/office/drawing/2014/main" id="{AF4B9E8A-D3D0-393B-0F3B-42C9C3E877D8}"/>
-              </a:ext>
-            </a:extLst>
-          </p:cNvPr>
-          <p:cNvCxnSpPr>
-            <a:cxnSpLocks/>
-          </p:cNvCxnSpPr>
-          <p:nvPr/>
-        </p:nvCxnSpPr>
-        <p:spPr>
-          <a:xfrm>
-            <a:off x="6550614" y="5559552"/>
-            <a:ext cx="0" cy="576939"/>
-          </a:xfrm>
-          <a:prstGeom prst="line">
-            <a:avLst/>
-          </a:prstGeom>
-          <a:ln>
-            <a:solidFill>
-              <a:schemeClr val="tx1"/>
-            </a:solidFill>
-            <a:prstDash val="dash"/>
-          </a:ln>
-        </p:spPr>
-        <p:style>
-          <a:lnRef idx="1">
-            <a:schemeClr val="accent1"/>
-          </a:lnRef>
-          <a:fillRef idx="0">
-            <a:schemeClr val="accent1"/>
-          </a:fillRef>
-          <a:effectRef idx="0">
-            <a:schemeClr val="accent1"/>
-          </a:effectRef>
-          <a:fontRef idx="minor">
-            <a:schemeClr val="tx1"/>
-          </a:fontRef>
-        </p:style>
-      </p:cxnSp>
-      <p:cxnSp>
-        <p:nvCxnSpPr>
-          <p:cNvPr id="10" name="Straight Connector 9">
-            <a:extLst>
-              <a:ext uri="{FF2B5EF4-FFF2-40B4-BE49-F238E27FC236}">
-                <a16:creationId xmlns:a16="http://schemas.microsoft.com/office/drawing/2014/main" id="{F844211F-6B62-2DF3-155B-F8B55F40E33A}"/>
-              </a:ext>
-            </a:extLst>
-          </p:cNvPr>
-          <p:cNvCxnSpPr>
-            <a:cxnSpLocks/>
-          </p:cNvCxnSpPr>
-          <p:nvPr/>
-        </p:nvCxnSpPr>
-        <p:spPr>
-          <a:xfrm>
-            <a:off x="2941782" y="3862147"/>
-            <a:ext cx="0" cy="2386253"/>
-          </a:xfrm>
-          <a:prstGeom prst="line">
-            <a:avLst/>
-          </a:prstGeom>
-          <a:ln>
-            <a:solidFill>
-              <a:schemeClr val="tx1"/>
-            </a:solidFill>
-            <a:prstDash val="dash"/>
-          </a:ln>
-        </p:spPr>
-        <p:style>
-          <a:lnRef idx="1">
-            <a:schemeClr val="accent1"/>
-          </a:lnRef>
-          <a:fillRef idx="0">
-            <a:schemeClr val="accent1"/>
-          </a:fillRef>
-          <a:effectRef idx="0">
-            <a:schemeClr val="accent1"/>
-          </a:effectRef>
-          <a:fontRef idx="minor">
-            <a:schemeClr val="tx1"/>
-          </a:fontRef>
-        </p:style>
-      </p:cxnSp>
-      <p:cxnSp>
-        <p:nvCxnSpPr>
-          <p:cNvPr id="21" name="Straight Arrow Connector 20">
-            <a:extLst>
-              <a:ext uri="{FF2B5EF4-FFF2-40B4-BE49-F238E27FC236}">
-                <a16:creationId xmlns:a16="http://schemas.microsoft.com/office/drawing/2014/main" id="{70E7C15F-4CD4-9C43-BD1D-D907E35AD5D9}"/>
-              </a:ext>
-            </a:extLst>
-          </p:cNvPr>
-          <p:cNvCxnSpPr/>
-          <p:nvPr/>
-        </p:nvCxnSpPr>
-        <p:spPr>
-          <a:xfrm>
-            <a:off x="2941782" y="5985181"/>
-            <a:ext cx="3608832" cy="0"/>
-          </a:xfrm>
-          <a:prstGeom prst="straightConnector1">
-            <a:avLst/>
-          </a:prstGeom>
-          <a:ln w="28575">
-            <a:solidFill>
-              <a:schemeClr val="tx1"/>
-            </a:solidFill>
-            <a:headEnd type="triangle"/>
-            <a:tailEnd type="triangle"/>
-          </a:ln>
-        </p:spPr>
-        <p:style>
-          <a:lnRef idx="1">
-            <a:schemeClr val="accent1"/>
-          </a:lnRef>
-          <a:fillRef idx="0">
-            <a:schemeClr val="accent1"/>
-          </a:fillRef>
-          <a:effectRef idx="0">
-            <a:schemeClr val="accent1"/>
-          </a:effectRef>
-          <a:fontRef idx="minor">
-            <a:schemeClr val="tx1"/>
-          </a:fontRef>
-        </p:style>
-      </p:cxnSp>
-      <p:sp>
-        <p:nvSpPr>
-          <p:cNvPr id="22" name="TextBox 21">
-            <a:extLst>
-              <a:ext uri="{FF2B5EF4-FFF2-40B4-BE49-F238E27FC236}">
-                <a16:creationId xmlns:a16="http://schemas.microsoft.com/office/drawing/2014/main" id="{FF579F81-C611-AF56-9E16-81264727CD9E}"/>
-              </a:ext>
-            </a:extLst>
-          </p:cNvPr>
-          <p:cNvSpPr txBox="1"/>
-          <p:nvPr/>
-        </p:nvSpPr>
-        <p:spPr>
-          <a:xfrm>
-            <a:off x="4625014" y="5816103"/>
-            <a:ext cx="282450" cy="369332"/>
-          </a:xfrm>
-          <a:prstGeom prst="rect">
-            <a:avLst/>
-          </a:prstGeom>
-          <a:solidFill>
-            <a:schemeClr val="bg1"/>
-          </a:solidFill>
-        </p:spPr>
-        <p:txBody>
-          <a:bodyPr wrap="none" rtlCol="0">
-            <a:spAutoFit/>
-          </a:bodyPr>
-          <a:lstStyle/>
-          <a:p>
-            <a:r>
-              <a:rPr lang="en-US" dirty="0"/>
-              <a:t>L</a:t>
-            </a:r>
-          </a:p>
-        </p:txBody>
-      </p:sp>
-      <p:cxnSp>
-        <p:nvCxnSpPr>
-          <p:cNvPr id="23" name="Straight Arrow Connector 22">
-            <a:extLst>
-              <a:ext uri="{FF2B5EF4-FFF2-40B4-BE49-F238E27FC236}">
-                <a16:creationId xmlns:a16="http://schemas.microsoft.com/office/drawing/2014/main" id="{3E42D5FE-1662-1927-3CF2-EC86929AF629}"/>
-              </a:ext>
-            </a:extLst>
-          </p:cNvPr>
-          <p:cNvCxnSpPr>
-            <a:cxnSpLocks/>
-          </p:cNvCxnSpPr>
-          <p:nvPr/>
-        </p:nvCxnSpPr>
-        <p:spPr>
-          <a:xfrm>
-            <a:off x="2941782" y="5471157"/>
-            <a:ext cx="889554" cy="0"/>
-          </a:xfrm>
-          <a:prstGeom prst="straightConnector1">
-            <a:avLst/>
-          </a:prstGeom>
-          <a:ln w="12700">
-            <a:solidFill>
-              <a:schemeClr val="tx1"/>
-            </a:solidFill>
-            <a:headEnd type="triangle"/>
-            <a:tailEnd type="triangle"/>
-          </a:ln>
-        </p:spPr>
-        <p:style>
-          <a:lnRef idx="1">
-            <a:schemeClr val="accent1"/>
-          </a:lnRef>
-          <a:fillRef idx="0">
-            <a:schemeClr val="accent1"/>
-          </a:fillRef>
-          <a:effectRef idx="0">
-            <a:schemeClr val="accent1"/>
-          </a:effectRef>
-          <a:fontRef idx="minor">
-            <a:schemeClr val="tx1"/>
-          </a:fontRef>
-        </p:style>
-      </p:cxnSp>
-      <p:sp>
-        <p:nvSpPr>
-          <p:cNvPr id="25" name="TextBox 24">
-            <a:extLst>
-              <a:ext uri="{FF2B5EF4-FFF2-40B4-BE49-F238E27FC236}">
-                <a16:creationId xmlns:a16="http://schemas.microsoft.com/office/drawing/2014/main" id="{2BEE2BAD-9820-2BD8-B7AC-ADC9829791B3}"/>
-              </a:ext>
-            </a:extLst>
-          </p:cNvPr>
-          <p:cNvSpPr txBox="1"/>
-          <p:nvPr/>
-        </p:nvSpPr>
-        <p:spPr>
-          <a:xfrm>
-            <a:off x="3247687" y="5318083"/>
-            <a:ext cx="260008" cy="369332"/>
-          </a:xfrm>
-          <a:prstGeom prst="rect">
-            <a:avLst/>
-          </a:prstGeom>
-          <a:solidFill>
-            <a:schemeClr val="bg1"/>
-          </a:solidFill>
-        </p:spPr>
-        <p:txBody>
-          <a:bodyPr wrap="none" rtlCol="0">
-            <a:spAutoFit/>
-          </a:bodyPr>
-          <a:lstStyle/>
-          <a:p>
-            <a:r>
-              <a:rPr lang="en-US" dirty="0">
-                <a:latin typeface="Script MT Bold" panose="03040602040607080904" pitchFamily="66" charset="0"/>
-              </a:rPr>
-              <a:t>l</a:t>
-            </a:r>
-            <a:endParaRPr lang="en-US" dirty="0"/>
-          </a:p>
-        </p:txBody>
-      </p:sp>
-    </p:spTree>
-    <p:extLst>
-      <p:ext uri="{BB962C8B-B14F-4D97-AF65-F5344CB8AC3E}">
-        <p14:creationId xmlns:p14="http://schemas.microsoft.com/office/powerpoint/2010/main" val="855844419"/>
-      </p:ext>
-    </p:extLst>
-  </p:cSld>
-  <p:clrMapOvr>
-    <a:masterClrMapping/>
-  </p:clrMapOvr>
-</p:sld>
-</file>
-
-<file path=ppt/slides/slide32.xml><?xml version="1.0" encoding="utf-8"?>
-<p:sld xmlns:a="http://schemas.openxmlformats.org/drawingml/2006/main" xmlns:r="http://schemas.openxmlformats.org/officeDocument/2006/relationships" xmlns:p="http://schemas.openxmlformats.org/presentationml/2006/main">
-  <p:cSld>
-    <p:spTree>
-      <p:nvGrpSpPr>
-        <p:cNvPr id="1" name=""/>
-        <p:cNvGrpSpPr/>
-        <p:nvPr/>
-      </p:nvGrpSpPr>
-      <p:grpSpPr>
-        <a:xfrm>
-          <a:off x="0" y="0"/>
-          <a:ext cx="0" cy="0"/>
-          <a:chOff x="0" y="0"/>
-          <a:chExt cx="0" cy="0"/>
-        </a:xfrm>
-      </p:grpSpPr>
-      <p:sp>
-        <p:nvSpPr>
-          <p:cNvPr id="2" name="Title 1">
-            <a:extLst>
-              <a:ext uri="{FF2B5EF4-FFF2-40B4-BE49-F238E27FC236}">
-                <a16:creationId xmlns:a16="http://schemas.microsoft.com/office/drawing/2014/main" id="{1062A867-10CE-CCEE-1AF5-5945F8C5CF81}"/>
-              </a:ext>
-            </a:extLst>
-          </p:cNvPr>
-          <p:cNvSpPr>
-            <a:spLocks noGrp="1"/>
-          </p:cNvSpPr>
-          <p:nvPr>
-            <p:ph type="ctrTitle"/>
-          </p:nvPr>
-        </p:nvSpPr>
-        <p:spPr/>
-        <p:txBody>
-          <a:bodyPr/>
-          <a:lstStyle/>
-          <a:p>
-            <a:r>
-              <a:rPr lang="en-US" dirty="0"/>
-              <a:t>END</a:t>
-            </a:r>
-          </a:p>
-        </p:txBody>
-      </p:sp>
-      <p:sp>
-        <p:nvSpPr>
-          <p:cNvPr id="3" name="Subtitle 2">
-            <a:extLst>
-              <a:ext uri="{FF2B5EF4-FFF2-40B4-BE49-F238E27FC236}">
-                <a16:creationId xmlns:a16="http://schemas.microsoft.com/office/drawing/2014/main" id="{B729B2DC-9D67-EA05-E426-34867E0B9300}"/>
-              </a:ext>
-            </a:extLst>
-          </p:cNvPr>
-          <p:cNvSpPr>
-            <a:spLocks noGrp="1"/>
-          </p:cNvSpPr>
-          <p:nvPr>
-            <p:ph type="subTitle" idx="1"/>
-          </p:nvPr>
-        </p:nvSpPr>
-        <p:spPr/>
-        <p:txBody>
-          <a:bodyPr/>
-          <a:lstStyle/>
-          <a:p>
-            <a:endParaRPr lang="en-US"/>
-          </a:p>
-        </p:txBody>
-      </p:sp>
-    </p:spTree>
-    <p:extLst>
-      <p:ext uri="{BB962C8B-B14F-4D97-AF65-F5344CB8AC3E}">
-        <p14:creationId xmlns:p14="http://schemas.microsoft.com/office/powerpoint/2010/main" val="2869578996"/>
-      </p:ext>
-    </p:extLst>
-  </p:cSld>
-  <p:clrMapOvr>
-    <a:masterClrMapping/>
-  </p:clrMapOvr>
-</p:sld>
-</file>
-
-<file path=ppt/slides/slide33.xml><?xml version="1.0" encoding="utf-8"?>
+<file path=ppt/slides/slide36.xml><?xml version="1.0" encoding="utf-8"?>
 <p:sld xmlns:a="http://schemas.openxmlformats.org/drawingml/2006/main" xmlns:r="http://schemas.openxmlformats.org/officeDocument/2006/relationships" xmlns:p="http://schemas.openxmlformats.org/presentationml/2006/main">
   <p:cSld>
     <p:spTree>
@@ -10938,7 +11450,7 @@
             <a:fld id="{D9522729-DB03-484C-B934-8304638AC9B4}" type="slidenum">
               <a:rPr lang="en-US" smtClean="0"/>
               <a:pPr/>
-              <a:t>33</a:t>
+              <a:t>36</a:t>
             </a:fld>
             <a:endParaRPr lang="en-US"/>
           </a:p>
@@ -11136,7 +11648,7 @@
 </p:sld>
 </file>
 
-<file path=ppt/slides/slide34.xml><?xml version="1.0" encoding="utf-8"?>
+<file path=ppt/slides/slide37.xml><?xml version="1.0" encoding="utf-8"?>
 <p:sld xmlns:a="http://schemas.openxmlformats.org/drawingml/2006/main" xmlns:r="http://schemas.openxmlformats.org/officeDocument/2006/relationships" xmlns:p="http://schemas.openxmlformats.org/presentationml/2006/main">
   <p:cSld>
     <p:spTree>
@@ -12037,7 +12549,7 @@
 </p:sld>
 </file>
 
-<file path=ppt/slides/slide35.xml><?xml version="1.0" encoding="utf-8"?>
+<file path=ppt/slides/slide38.xml><?xml version="1.0" encoding="utf-8"?>
 <p:sld xmlns:a="http://schemas.openxmlformats.org/drawingml/2006/main" xmlns:r="http://schemas.openxmlformats.org/officeDocument/2006/relationships" xmlns:p="http://schemas.openxmlformats.org/presentationml/2006/main">
   <p:cSld>
     <p:spTree>
@@ -13427,7 +13939,7 @@
 </p:sld>
 </file>
 
-<file path=ppt/slides/slide36.xml><?xml version="1.0" encoding="utf-8"?>
+<file path=ppt/slides/slide39.xml><?xml version="1.0" encoding="utf-8"?>
 <p:sld xmlns:a="http://schemas.openxmlformats.org/drawingml/2006/main" xmlns:r="http://schemas.openxmlformats.org/officeDocument/2006/relationships" xmlns:p="http://schemas.openxmlformats.org/presentationml/2006/main">
   <p:cSld>
     <p:spTree>
@@ -13562,7 +14074,7 @@
               <a:pPr>
                 <a:defRPr/>
               </a:pPr>
-              <a:t>36</a:t>
+              <a:t>39</a:t>
             </a:fld>
             <a:endParaRPr lang="en-US"/>
           </a:p>
@@ -13572,468 +14084,6 @@
     <p:extLst>
       <p:ext uri="{BB962C8B-B14F-4D97-AF65-F5344CB8AC3E}">
         <p14:creationId xmlns:p14="http://schemas.microsoft.com/office/powerpoint/2010/main" val="1016616832"/>
-      </p:ext>
-    </p:extLst>
-  </p:cSld>
-  <p:clrMapOvr>
-    <a:masterClrMapping/>
-  </p:clrMapOvr>
-</p:sld>
-</file>
-
-<file path=ppt/slides/slide37.xml><?xml version="1.0" encoding="utf-8"?>
-<p:sld xmlns:a="http://schemas.openxmlformats.org/drawingml/2006/main" xmlns:r="http://schemas.openxmlformats.org/officeDocument/2006/relationships" xmlns:p="http://schemas.openxmlformats.org/presentationml/2006/main">
-  <p:cSld>
-    <p:spTree>
-      <p:nvGrpSpPr>
-        <p:cNvPr id="1" name=""/>
-        <p:cNvGrpSpPr/>
-        <p:nvPr/>
-      </p:nvGrpSpPr>
-      <p:grpSpPr>
-        <a:xfrm>
-          <a:off x="0" y="0"/>
-          <a:ext cx="0" cy="0"/>
-          <a:chOff x="0" y="0"/>
-          <a:chExt cx="0" cy="0"/>
-        </a:xfrm>
-      </p:grpSpPr>
-      <p:pic>
-        <p:nvPicPr>
-          <p:cNvPr id="28674" name="Picture 4" descr="neuro4e-fig-11-02-0"/>
-          <p:cNvPicPr>
-            <a:picLocks noChangeAspect="1" noChangeArrowheads="1"/>
-          </p:cNvPicPr>
-          <p:nvPr/>
-        </p:nvPicPr>
-        <p:blipFill>
-          <a:blip r:embed="rId3" cstate="print"/>
-          <a:srcRect/>
-          <a:stretch>
-            <a:fillRect/>
-          </a:stretch>
-        </p:blipFill>
-        <p:spPr bwMode="auto">
-          <a:xfrm>
-            <a:off x="4191000" y="1143000"/>
-            <a:ext cx="4854575" cy="3581400"/>
-          </a:xfrm>
-          <a:prstGeom prst="rect">
-            <a:avLst/>
-          </a:prstGeom>
-          <a:noFill/>
-          <a:ln w="9525">
-            <a:noFill/>
-            <a:miter lim="800000"/>
-            <a:headEnd/>
-            <a:tailEnd/>
-          </a:ln>
-        </p:spPr>
-      </p:pic>
-      <p:sp>
-        <p:nvSpPr>
-          <p:cNvPr id="28675" name="Rectangle 2"/>
-          <p:cNvSpPr>
-            <a:spLocks noGrp="1" noChangeArrowheads="1"/>
-          </p:cNvSpPr>
-          <p:nvPr>
-            <p:ph type="title"/>
-          </p:nvPr>
-        </p:nvSpPr>
-        <p:spPr>
-          <a:xfrm>
-            <a:off x="457200" y="381000"/>
-            <a:ext cx="8229600" cy="609600"/>
-          </a:xfrm>
-        </p:spPr>
-        <p:txBody>
-          <a:bodyPr>
-            <a:normAutofit fontScale="90000"/>
-          </a:bodyPr>
-          <a:lstStyle/>
-          <a:p>
-            <a:r>
-              <a:rPr lang="en-US" sz="4000" dirty="0">
-                <a:solidFill>
-                  <a:srgbClr val="00B050"/>
-                </a:solidFill>
-              </a:rPr>
-              <a:t>Accommodation by the Lens</a:t>
-            </a:r>
-          </a:p>
-        </p:txBody>
-      </p:sp>
-      <p:sp>
-        <p:nvSpPr>
-          <p:cNvPr id="28676" name="Content Placeholder 4"/>
-          <p:cNvSpPr>
-            <a:spLocks noGrp="1"/>
-          </p:cNvSpPr>
-          <p:nvPr>
-            <p:ph idx="1"/>
-          </p:nvPr>
-        </p:nvSpPr>
-        <p:spPr>
-          <a:xfrm>
-            <a:off x="228600" y="1219200"/>
-            <a:ext cx="3810000" cy="5257800"/>
-          </a:xfrm>
-        </p:spPr>
-        <p:txBody>
-          <a:bodyPr/>
-          <a:lstStyle/>
-          <a:p>
-            <a:r>
-              <a:rPr lang="en-US" sz="2000"/>
-              <a:t>Accommodation refers to  dynamic changes in the shape of the lens.</a:t>
-            </a:r>
-          </a:p>
-          <a:p>
-            <a:r>
-              <a:rPr lang="en-US" sz="2000"/>
-              <a:t>As an object comes within about 20 feet the light rays originating at a point are no longer considered to be parallel.</a:t>
-            </a:r>
-          </a:p>
-          <a:p>
-            <a:r>
-              <a:rPr lang="en-US" sz="2000"/>
-              <a:t>Rather these light rays diverge and a greater refractive power is required to bring them into focus. </a:t>
-            </a:r>
-          </a:p>
-          <a:p>
-            <a:r>
-              <a:rPr lang="en-US" sz="2000"/>
-              <a:t>The lens can contribute about 12 or more diopters to the focusing of light rays on the back of the eye by rounding up.</a:t>
-            </a:r>
-          </a:p>
-        </p:txBody>
-      </p:sp>
-    </p:spTree>
-    <p:extLst>
-      <p:ext uri="{BB962C8B-B14F-4D97-AF65-F5344CB8AC3E}">
-        <p14:creationId xmlns:p14="http://schemas.microsoft.com/office/powerpoint/2010/main" val="2939919856"/>
-      </p:ext>
-    </p:extLst>
-  </p:cSld>
-  <p:clrMapOvr>
-    <a:masterClrMapping/>
-  </p:clrMapOvr>
-</p:sld>
-</file>
-
-<file path=ppt/slides/slide38.xml><?xml version="1.0" encoding="utf-8"?>
-<p:sld xmlns:a="http://schemas.openxmlformats.org/drawingml/2006/main" xmlns:r="http://schemas.openxmlformats.org/officeDocument/2006/relationships" xmlns:p="http://schemas.openxmlformats.org/presentationml/2006/main">
-  <p:cSld>
-    <p:spTree>
-      <p:nvGrpSpPr>
-        <p:cNvPr id="1" name=""/>
-        <p:cNvGrpSpPr/>
-        <p:nvPr/>
-      </p:nvGrpSpPr>
-      <p:grpSpPr>
-        <a:xfrm>
-          <a:off x="0" y="0"/>
-          <a:ext cx="0" cy="0"/>
-          <a:chOff x="0" y="0"/>
-          <a:chExt cx="0" cy="0"/>
-        </a:xfrm>
-      </p:grpSpPr>
-      <p:sp>
-        <p:nvSpPr>
-          <p:cNvPr id="3" name="Title 2"/>
-          <p:cNvSpPr>
-            <a:spLocks noGrp="1"/>
-          </p:cNvSpPr>
-          <p:nvPr>
-            <p:ph type="title"/>
-          </p:nvPr>
-        </p:nvSpPr>
-        <p:spPr/>
-        <p:txBody>
-          <a:bodyPr/>
-          <a:lstStyle/>
-          <a:p>
-            <a:r>
-              <a:rPr lang="en-US" dirty="0"/>
-              <a:t>Question 223.18.3</a:t>
-            </a:r>
-          </a:p>
-        </p:txBody>
-      </p:sp>
-      <p:sp>
-        <p:nvSpPr>
-          <p:cNvPr id="4" name="Content Placeholder 3"/>
-          <p:cNvSpPr>
-            <a:spLocks noGrp="1"/>
-          </p:cNvSpPr>
-          <p:nvPr>
-            <p:ph idx="1"/>
-          </p:nvPr>
-        </p:nvSpPr>
-        <p:spPr/>
-        <p:txBody>
-          <a:bodyPr/>
-          <a:lstStyle/>
-          <a:p>
-            <a:pPr>
-              <a:buNone/>
-            </a:pPr>
-            <a:r>
-              <a:rPr lang="en-US" dirty="0"/>
-              <a:t>What do we call the position of the closest thing we can see?</a:t>
-            </a:r>
-          </a:p>
-          <a:p>
-            <a:pPr marL="514350" indent="-514350">
-              <a:buFont typeface="+mj-lt"/>
-              <a:buAutoNum type="alphaLcParenR"/>
-            </a:pPr>
-            <a:r>
-              <a:rPr lang="en-US" dirty="0"/>
-              <a:t>Near point</a:t>
-            </a:r>
-          </a:p>
-          <a:p>
-            <a:pPr marL="514350" indent="-514350">
-              <a:buFont typeface="+mj-lt"/>
-              <a:buAutoNum type="alphaLcParenR"/>
-            </a:pPr>
-            <a:r>
-              <a:rPr lang="en-US" dirty="0"/>
-              <a:t>Far point</a:t>
-            </a:r>
-          </a:p>
-          <a:p>
-            <a:pPr marL="514350" indent="-514350">
-              <a:buFont typeface="+mj-lt"/>
-              <a:buAutoNum type="alphaLcParenR"/>
-            </a:pPr>
-            <a:r>
-              <a:rPr lang="en-US" dirty="0"/>
-              <a:t>Squint point</a:t>
-            </a:r>
-          </a:p>
-          <a:p>
-            <a:pPr marL="514350" indent="-514350">
-              <a:buFont typeface="+mj-lt"/>
-              <a:buAutoNum type="alphaLcParenR"/>
-            </a:pPr>
-            <a:r>
-              <a:rPr lang="en-US" dirty="0"/>
-              <a:t>conjunctiva</a:t>
-            </a:r>
-          </a:p>
-        </p:txBody>
-      </p:sp>
-      <p:sp>
-        <p:nvSpPr>
-          <p:cNvPr id="2" name="Slide Number Placeholder 1"/>
-          <p:cNvSpPr>
-            <a:spLocks noGrp="1"/>
-          </p:cNvSpPr>
-          <p:nvPr>
-            <p:ph type="sldNum" sz="quarter" idx="12"/>
-          </p:nvPr>
-        </p:nvSpPr>
-        <p:spPr/>
-        <p:txBody>
-          <a:bodyPr/>
-          <a:lstStyle/>
-          <a:p>
-            <a:pPr>
-              <a:defRPr/>
-            </a:pPr>
-            <a:fld id="{7AD10819-D402-4D92-A9F3-11EFF80A1266}" type="slidenum">
-              <a:rPr lang="en-US" smtClean="0"/>
-              <a:pPr>
-                <a:defRPr/>
-              </a:pPr>
-              <a:t>38</a:t>
-            </a:fld>
-            <a:endParaRPr lang="en-US"/>
-          </a:p>
-        </p:txBody>
-      </p:sp>
-    </p:spTree>
-    <p:extLst>
-      <p:ext uri="{BB962C8B-B14F-4D97-AF65-F5344CB8AC3E}">
-        <p14:creationId xmlns:p14="http://schemas.microsoft.com/office/powerpoint/2010/main" val="1496377247"/>
-      </p:ext>
-    </p:extLst>
-  </p:cSld>
-  <p:clrMapOvr>
-    <a:masterClrMapping/>
-  </p:clrMapOvr>
-</p:sld>
-</file>
-
-<file path=ppt/slides/slide39.xml><?xml version="1.0" encoding="utf-8"?>
-<p:sld xmlns:a="http://schemas.openxmlformats.org/drawingml/2006/main" xmlns:r="http://schemas.openxmlformats.org/officeDocument/2006/relationships" xmlns:p="http://schemas.openxmlformats.org/presentationml/2006/main">
-  <p:cSld>
-    <p:spTree>
-      <p:nvGrpSpPr>
-        <p:cNvPr id="1" name=""/>
-        <p:cNvGrpSpPr/>
-        <p:nvPr/>
-      </p:nvGrpSpPr>
-      <p:grpSpPr>
-        <a:xfrm>
-          <a:off x="0" y="0"/>
-          <a:ext cx="0" cy="0"/>
-          <a:chOff x="0" y="0"/>
-          <a:chExt cx="0" cy="0"/>
-        </a:xfrm>
-      </p:grpSpPr>
-      <p:pic>
-        <p:nvPicPr>
-          <p:cNvPr id="29698" name="Picture 4" descr="neuro4e-box-11-a(1)-0"/>
-          <p:cNvPicPr>
-            <a:picLocks noChangeAspect="1" noChangeArrowheads="1"/>
-          </p:cNvPicPr>
-          <p:nvPr/>
-        </p:nvPicPr>
-        <p:blipFill>
-          <a:blip r:embed="rId3" cstate="print"/>
-          <a:srcRect l="30489" r="28049" b="6947"/>
-          <a:stretch>
-            <a:fillRect/>
-          </a:stretch>
-        </p:blipFill>
-        <p:spPr bwMode="auto">
-          <a:xfrm>
-            <a:off x="5410200" y="1371600"/>
-            <a:ext cx="2971800" cy="5011738"/>
-          </a:xfrm>
-          <a:prstGeom prst="rect">
-            <a:avLst/>
-          </a:prstGeom>
-          <a:noFill/>
-          <a:ln w="9525">
-            <a:noFill/>
-            <a:miter lim="800000"/>
-            <a:headEnd/>
-            <a:tailEnd/>
-          </a:ln>
-        </p:spPr>
-      </p:pic>
-      <p:sp>
-        <p:nvSpPr>
-          <p:cNvPr id="29699" name="Rectangle 2"/>
-          <p:cNvSpPr>
-            <a:spLocks noGrp="1" noChangeArrowheads="1"/>
-          </p:cNvSpPr>
-          <p:nvPr>
-            <p:ph type="title"/>
-          </p:nvPr>
-        </p:nvSpPr>
-        <p:spPr/>
-        <p:txBody>
-          <a:bodyPr/>
-          <a:lstStyle/>
-          <a:p>
-            <a:pPr eaLnBrk="1" hangingPunct="1"/>
-            <a:r>
-              <a:rPr lang="en-US" sz="3200" dirty="0"/>
-              <a:t>Myopia and Other Refractive Errors</a:t>
-            </a:r>
-          </a:p>
-        </p:txBody>
-      </p:sp>
-      <p:sp>
-        <p:nvSpPr>
-          <p:cNvPr id="29700" name="Content Placeholder 3"/>
-          <p:cNvSpPr>
-            <a:spLocks noGrp="1"/>
-          </p:cNvSpPr>
-          <p:nvPr>
-            <p:ph idx="1"/>
-          </p:nvPr>
-        </p:nvSpPr>
-        <p:spPr>
-          <a:xfrm>
-            <a:off x="228600" y="1295400"/>
-            <a:ext cx="5029200" cy="4724400"/>
-          </a:xfrm>
-        </p:spPr>
-        <p:txBody>
-          <a:bodyPr/>
-          <a:lstStyle/>
-          <a:p>
-            <a:r>
-              <a:rPr lang="en-US" sz="2400" dirty="0">
-                <a:solidFill>
-                  <a:srgbClr val="00B050"/>
-                </a:solidFill>
-              </a:rPr>
-              <a:t>Myopia </a:t>
-            </a:r>
-            <a:r>
-              <a:rPr lang="en-US" sz="2400" dirty="0"/>
-              <a:t>– nearsightedness </a:t>
-            </a:r>
-          </a:p>
-          <a:p>
-            <a:pPr lvl="1"/>
-            <a:r>
-              <a:rPr lang="en-US" sz="2000" dirty="0"/>
-              <a:t>The ability to see close objects clearly but distant objects are blurry</a:t>
-            </a:r>
-          </a:p>
-          <a:p>
-            <a:pPr lvl="1"/>
-            <a:r>
-              <a:rPr lang="en-US" sz="2000" dirty="0"/>
-              <a:t>Cornea and lens focus object in front of the retina</a:t>
-            </a:r>
-          </a:p>
-          <a:p>
-            <a:pPr lvl="1"/>
-            <a:r>
-              <a:rPr lang="en-US" sz="2000" dirty="0"/>
-              <a:t>Corrected by concave lens (minus lens), radial keratotomy, laser corneal sculpting.</a:t>
-            </a:r>
-          </a:p>
-          <a:p>
-            <a:r>
-              <a:rPr lang="en-US" sz="2400" dirty="0" err="1">
-                <a:solidFill>
-                  <a:srgbClr val="00B050"/>
-                </a:solidFill>
-              </a:rPr>
-              <a:t>Hyperopia</a:t>
-            </a:r>
-            <a:r>
-              <a:rPr lang="en-US" sz="2400" dirty="0"/>
-              <a:t> - farsightedness</a:t>
-            </a:r>
-          </a:p>
-          <a:p>
-            <a:pPr lvl="1"/>
-            <a:r>
-              <a:rPr lang="en-US" sz="2000" dirty="0"/>
-              <a:t>Ability to see distant objects but close objects are blurry</a:t>
-            </a:r>
-          </a:p>
-          <a:p>
-            <a:pPr lvl="1"/>
-            <a:r>
-              <a:rPr lang="en-US" sz="2000" dirty="0"/>
-              <a:t>Image is focused behind the retina.</a:t>
-            </a:r>
-          </a:p>
-          <a:p>
-            <a:pPr lvl="1"/>
-            <a:r>
-              <a:rPr lang="en-US" sz="2000" dirty="0"/>
-              <a:t>Corrected by convex lenses.</a:t>
-            </a:r>
-          </a:p>
-        </p:txBody>
-      </p:sp>
-    </p:spTree>
-    <p:extLst>
-      <p:ext uri="{BB962C8B-B14F-4D97-AF65-F5344CB8AC3E}">
-        <p14:creationId xmlns:p14="http://schemas.microsoft.com/office/powerpoint/2010/main" val="1598000771"/>
       </p:ext>
     </p:extLst>
   </p:cSld>
@@ -15450,6 +15500,468 @@
           <a:chExt cx="0" cy="0"/>
         </a:xfrm>
       </p:grpSpPr>
+      <p:pic>
+        <p:nvPicPr>
+          <p:cNvPr id="28674" name="Picture 4" descr="neuro4e-fig-11-02-0"/>
+          <p:cNvPicPr>
+            <a:picLocks noChangeAspect="1" noChangeArrowheads="1"/>
+          </p:cNvPicPr>
+          <p:nvPr/>
+        </p:nvPicPr>
+        <p:blipFill>
+          <a:blip r:embed="rId3" cstate="print"/>
+          <a:srcRect/>
+          <a:stretch>
+            <a:fillRect/>
+          </a:stretch>
+        </p:blipFill>
+        <p:spPr bwMode="auto">
+          <a:xfrm>
+            <a:off x="4191000" y="1143000"/>
+            <a:ext cx="4854575" cy="3581400"/>
+          </a:xfrm>
+          <a:prstGeom prst="rect">
+            <a:avLst/>
+          </a:prstGeom>
+          <a:noFill/>
+          <a:ln w="9525">
+            <a:noFill/>
+            <a:miter lim="800000"/>
+            <a:headEnd/>
+            <a:tailEnd/>
+          </a:ln>
+        </p:spPr>
+      </p:pic>
+      <p:sp>
+        <p:nvSpPr>
+          <p:cNvPr id="28675" name="Rectangle 2"/>
+          <p:cNvSpPr>
+            <a:spLocks noGrp="1" noChangeArrowheads="1"/>
+          </p:cNvSpPr>
+          <p:nvPr>
+            <p:ph type="title"/>
+          </p:nvPr>
+        </p:nvSpPr>
+        <p:spPr>
+          <a:xfrm>
+            <a:off x="457200" y="381000"/>
+            <a:ext cx="8229600" cy="609600"/>
+          </a:xfrm>
+        </p:spPr>
+        <p:txBody>
+          <a:bodyPr>
+            <a:normAutofit fontScale="90000"/>
+          </a:bodyPr>
+          <a:lstStyle/>
+          <a:p>
+            <a:r>
+              <a:rPr lang="en-US" sz="4000" dirty="0">
+                <a:solidFill>
+                  <a:srgbClr val="00B050"/>
+                </a:solidFill>
+              </a:rPr>
+              <a:t>Accommodation by the Lens</a:t>
+            </a:r>
+          </a:p>
+        </p:txBody>
+      </p:sp>
+      <p:sp>
+        <p:nvSpPr>
+          <p:cNvPr id="28676" name="Content Placeholder 4"/>
+          <p:cNvSpPr>
+            <a:spLocks noGrp="1"/>
+          </p:cNvSpPr>
+          <p:nvPr>
+            <p:ph idx="1"/>
+          </p:nvPr>
+        </p:nvSpPr>
+        <p:spPr>
+          <a:xfrm>
+            <a:off x="228600" y="1219200"/>
+            <a:ext cx="3810000" cy="5257800"/>
+          </a:xfrm>
+        </p:spPr>
+        <p:txBody>
+          <a:bodyPr/>
+          <a:lstStyle/>
+          <a:p>
+            <a:r>
+              <a:rPr lang="en-US" sz="2000"/>
+              <a:t>Accommodation refers to  dynamic changes in the shape of the lens.</a:t>
+            </a:r>
+          </a:p>
+          <a:p>
+            <a:r>
+              <a:rPr lang="en-US" sz="2000"/>
+              <a:t>As an object comes within about 20 feet the light rays originating at a point are no longer considered to be parallel.</a:t>
+            </a:r>
+          </a:p>
+          <a:p>
+            <a:r>
+              <a:rPr lang="en-US" sz="2000"/>
+              <a:t>Rather these light rays diverge and a greater refractive power is required to bring them into focus. </a:t>
+            </a:r>
+          </a:p>
+          <a:p>
+            <a:r>
+              <a:rPr lang="en-US" sz="2000"/>
+              <a:t>The lens can contribute about 12 or more diopters to the focusing of light rays on the back of the eye by rounding up.</a:t>
+            </a:r>
+          </a:p>
+        </p:txBody>
+      </p:sp>
+    </p:spTree>
+    <p:extLst>
+      <p:ext uri="{BB962C8B-B14F-4D97-AF65-F5344CB8AC3E}">
+        <p14:creationId xmlns:p14="http://schemas.microsoft.com/office/powerpoint/2010/main" val="2939919856"/>
+      </p:ext>
+    </p:extLst>
+  </p:cSld>
+  <p:clrMapOvr>
+    <a:masterClrMapping/>
+  </p:clrMapOvr>
+</p:sld>
+</file>
+
+<file path=ppt/slides/slide41.xml><?xml version="1.0" encoding="utf-8"?>
+<p:sld xmlns:a="http://schemas.openxmlformats.org/drawingml/2006/main" xmlns:r="http://schemas.openxmlformats.org/officeDocument/2006/relationships" xmlns:p="http://schemas.openxmlformats.org/presentationml/2006/main">
+  <p:cSld>
+    <p:spTree>
+      <p:nvGrpSpPr>
+        <p:cNvPr id="1" name=""/>
+        <p:cNvGrpSpPr/>
+        <p:nvPr/>
+      </p:nvGrpSpPr>
+      <p:grpSpPr>
+        <a:xfrm>
+          <a:off x="0" y="0"/>
+          <a:ext cx="0" cy="0"/>
+          <a:chOff x="0" y="0"/>
+          <a:chExt cx="0" cy="0"/>
+        </a:xfrm>
+      </p:grpSpPr>
+      <p:sp>
+        <p:nvSpPr>
+          <p:cNvPr id="3" name="Title 2"/>
+          <p:cNvSpPr>
+            <a:spLocks noGrp="1"/>
+          </p:cNvSpPr>
+          <p:nvPr>
+            <p:ph type="title"/>
+          </p:nvPr>
+        </p:nvSpPr>
+        <p:spPr/>
+        <p:txBody>
+          <a:bodyPr/>
+          <a:lstStyle/>
+          <a:p>
+            <a:r>
+              <a:rPr lang="en-US" dirty="0"/>
+              <a:t>Question 223.18.3</a:t>
+            </a:r>
+          </a:p>
+        </p:txBody>
+      </p:sp>
+      <p:sp>
+        <p:nvSpPr>
+          <p:cNvPr id="4" name="Content Placeholder 3"/>
+          <p:cNvSpPr>
+            <a:spLocks noGrp="1"/>
+          </p:cNvSpPr>
+          <p:nvPr>
+            <p:ph idx="1"/>
+          </p:nvPr>
+        </p:nvSpPr>
+        <p:spPr/>
+        <p:txBody>
+          <a:bodyPr/>
+          <a:lstStyle/>
+          <a:p>
+            <a:pPr>
+              <a:buNone/>
+            </a:pPr>
+            <a:r>
+              <a:rPr lang="en-US" dirty="0"/>
+              <a:t>What do we call the position of the closest thing we can see?</a:t>
+            </a:r>
+          </a:p>
+          <a:p>
+            <a:pPr marL="514350" indent="-514350">
+              <a:buFont typeface="+mj-lt"/>
+              <a:buAutoNum type="alphaLcParenR"/>
+            </a:pPr>
+            <a:r>
+              <a:rPr lang="en-US" dirty="0"/>
+              <a:t>Near point</a:t>
+            </a:r>
+          </a:p>
+          <a:p>
+            <a:pPr marL="514350" indent="-514350">
+              <a:buFont typeface="+mj-lt"/>
+              <a:buAutoNum type="alphaLcParenR"/>
+            </a:pPr>
+            <a:r>
+              <a:rPr lang="en-US" dirty="0"/>
+              <a:t>Far point</a:t>
+            </a:r>
+          </a:p>
+          <a:p>
+            <a:pPr marL="514350" indent="-514350">
+              <a:buFont typeface="+mj-lt"/>
+              <a:buAutoNum type="alphaLcParenR"/>
+            </a:pPr>
+            <a:r>
+              <a:rPr lang="en-US" dirty="0"/>
+              <a:t>Squint point</a:t>
+            </a:r>
+          </a:p>
+          <a:p>
+            <a:pPr marL="514350" indent="-514350">
+              <a:buFont typeface="+mj-lt"/>
+              <a:buAutoNum type="alphaLcParenR"/>
+            </a:pPr>
+            <a:r>
+              <a:rPr lang="en-US" dirty="0"/>
+              <a:t>conjunctiva</a:t>
+            </a:r>
+          </a:p>
+        </p:txBody>
+      </p:sp>
+      <p:sp>
+        <p:nvSpPr>
+          <p:cNvPr id="2" name="Slide Number Placeholder 1"/>
+          <p:cNvSpPr>
+            <a:spLocks noGrp="1"/>
+          </p:cNvSpPr>
+          <p:nvPr>
+            <p:ph type="sldNum" sz="quarter" idx="12"/>
+          </p:nvPr>
+        </p:nvSpPr>
+        <p:spPr/>
+        <p:txBody>
+          <a:bodyPr/>
+          <a:lstStyle/>
+          <a:p>
+            <a:pPr>
+              <a:defRPr/>
+            </a:pPr>
+            <a:fld id="{7AD10819-D402-4D92-A9F3-11EFF80A1266}" type="slidenum">
+              <a:rPr lang="en-US" smtClean="0"/>
+              <a:pPr>
+                <a:defRPr/>
+              </a:pPr>
+              <a:t>41</a:t>
+            </a:fld>
+            <a:endParaRPr lang="en-US"/>
+          </a:p>
+        </p:txBody>
+      </p:sp>
+    </p:spTree>
+    <p:extLst>
+      <p:ext uri="{BB962C8B-B14F-4D97-AF65-F5344CB8AC3E}">
+        <p14:creationId xmlns:p14="http://schemas.microsoft.com/office/powerpoint/2010/main" val="1496377247"/>
+      </p:ext>
+    </p:extLst>
+  </p:cSld>
+  <p:clrMapOvr>
+    <a:masterClrMapping/>
+  </p:clrMapOvr>
+</p:sld>
+</file>
+
+<file path=ppt/slides/slide42.xml><?xml version="1.0" encoding="utf-8"?>
+<p:sld xmlns:a="http://schemas.openxmlformats.org/drawingml/2006/main" xmlns:r="http://schemas.openxmlformats.org/officeDocument/2006/relationships" xmlns:p="http://schemas.openxmlformats.org/presentationml/2006/main">
+  <p:cSld>
+    <p:spTree>
+      <p:nvGrpSpPr>
+        <p:cNvPr id="1" name=""/>
+        <p:cNvGrpSpPr/>
+        <p:nvPr/>
+      </p:nvGrpSpPr>
+      <p:grpSpPr>
+        <a:xfrm>
+          <a:off x="0" y="0"/>
+          <a:ext cx="0" cy="0"/>
+          <a:chOff x="0" y="0"/>
+          <a:chExt cx="0" cy="0"/>
+        </a:xfrm>
+      </p:grpSpPr>
+      <p:pic>
+        <p:nvPicPr>
+          <p:cNvPr id="29698" name="Picture 4" descr="neuro4e-box-11-a(1)-0"/>
+          <p:cNvPicPr>
+            <a:picLocks noChangeAspect="1" noChangeArrowheads="1"/>
+          </p:cNvPicPr>
+          <p:nvPr/>
+        </p:nvPicPr>
+        <p:blipFill>
+          <a:blip r:embed="rId3" cstate="print"/>
+          <a:srcRect l="30489" r="28049" b="6947"/>
+          <a:stretch>
+            <a:fillRect/>
+          </a:stretch>
+        </p:blipFill>
+        <p:spPr bwMode="auto">
+          <a:xfrm>
+            <a:off x="5410200" y="1371600"/>
+            <a:ext cx="2971800" cy="5011738"/>
+          </a:xfrm>
+          <a:prstGeom prst="rect">
+            <a:avLst/>
+          </a:prstGeom>
+          <a:noFill/>
+          <a:ln w="9525">
+            <a:noFill/>
+            <a:miter lim="800000"/>
+            <a:headEnd/>
+            <a:tailEnd/>
+          </a:ln>
+        </p:spPr>
+      </p:pic>
+      <p:sp>
+        <p:nvSpPr>
+          <p:cNvPr id="29699" name="Rectangle 2"/>
+          <p:cNvSpPr>
+            <a:spLocks noGrp="1" noChangeArrowheads="1"/>
+          </p:cNvSpPr>
+          <p:nvPr>
+            <p:ph type="title"/>
+          </p:nvPr>
+        </p:nvSpPr>
+        <p:spPr/>
+        <p:txBody>
+          <a:bodyPr/>
+          <a:lstStyle/>
+          <a:p>
+            <a:pPr eaLnBrk="1" hangingPunct="1"/>
+            <a:r>
+              <a:rPr lang="en-US" sz="3200" dirty="0"/>
+              <a:t>Myopia and Other Refractive Errors</a:t>
+            </a:r>
+          </a:p>
+        </p:txBody>
+      </p:sp>
+      <p:sp>
+        <p:nvSpPr>
+          <p:cNvPr id="29700" name="Content Placeholder 3"/>
+          <p:cNvSpPr>
+            <a:spLocks noGrp="1"/>
+          </p:cNvSpPr>
+          <p:nvPr>
+            <p:ph idx="1"/>
+          </p:nvPr>
+        </p:nvSpPr>
+        <p:spPr>
+          <a:xfrm>
+            <a:off x="228600" y="1295400"/>
+            <a:ext cx="5029200" cy="4724400"/>
+          </a:xfrm>
+        </p:spPr>
+        <p:txBody>
+          <a:bodyPr/>
+          <a:lstStyle/>
+          <a:p>
+            <a:r>
+              <a:rPr lang="en-US" sz="2400" dirty="0">
+                <a:solidFill>
+                  <a:srgbClr val="00B050"/>
+                </a:solidFill>
+              </a:rPr>
+              <a:t>Myopia </a:t>
+            </a:r>
+            <a:r>
+              <a:rPr lang="en-US" sz="2400" dirty="0"/>
+              <a:t>– nearsightedness </a:t>
+            </a:r>
+          </a:p>
+          <a:p>
+            <a:pPr lvl="1"/>
+            <a:r>
+              <a:rPr lang="en-US" sz="2000" dirty="0"/>
+              <a:t>The ability to see close objects clearly but distant objects are blurry</a:t>
+            </a:r>
+          </a:p>
+          <a:p>
+            <a:pPr lvl="1"/>
+            <a:r>
+              <a:rPr lang="en-US" sz="2000" dirty="0"/>
+              <a:t>Cornea and lens focus object in front of the retina</a:t>
+            </a:r>
+          </a:p>
+          <a:p>
+            <a:pPr lvl="1"/>
+            <a:r>
+              <a:rPr lang="en-US" sz="2000" dirty="0"/>
+              <a:t>Corrected by concave lens (minus lens), radial keratotomy, laser corneal sculpting.</a:t>
+            </a:r>
+          </a:p>
+          <a:p>
+            <a:r>
+              <a:rPr lang="en-US" sz="2400" dirty="0" err="1">
+                <a:solidFill>
+                  <a:srgbClr val="00B050"/>
+                </a:solidFill>
+              </a:rPr>
+              <a:t>Hyperopia</a:t>
+            </a:r>
+            <a:r>
+              <a:rPr lang="en-US" sz="2400" dirty="0"/>
+              <a:t> - farsightedness</a:t>
+            </a:r>
+          </a:p>
+          <a:p>
+            <a:pPr lvl="1"/>
+            <a:r>
+              <a:rPr lang="en-US" sz="2000" dirty="0"/>
+              <a:t>Ability to see distant objects but close objects are blurry</a:t>
+            </a:r>
+          </a:p>
+          <a:p>
+            <a:pPr lvl="1"/>
+            <a:r>
+              <a:rPr lang="en-US" sz="2000" dirty="0"/>
+              <a:t>Image is focused behind the retina.</a:t>
+            </a:r>
+          </a:p>
+          <a:p>
+            <a:pPr lvl="1"/>
+            <a:r>
+              <a:rPr lang="en-US" sz="2000" dirty="0"/>
+              <a:t>Corrected by convex lenses.</a:t>
+            </a:r>
+          </a:p>
+        </p:txBody>
+      </p:sp>
+    </p:spTree>
+    <p:extLst>
+      <p:ext uri="{BB962C8B-B14F-4D97-AF65-F5344CB8AC3E}">
+        <p14:creationId xmlns:p14="http://schemas.microsoft.com/office/powerpoint/2010/main" val="1598000771"/>
+      </p:ext>
+    </p:extLst>
+  </p:cSld>
+  <p:clrMapOvr>
+    <a:masterClrMapping/>
+  </p:clrMapOvr>
+</p:sld>
+</file>
+
+<file path=ppt/slides/slide43.xml><?xml version="1.0" encoding="utf-8"?>
+<p:sld xmlns:a="http://schemas.openxmlformats.org/drawingml/2006/main" xmlns:r="http://schemas.openxmlformats.org/officeDocument/2006/relationships" xmlns:p="http://schemas.openxmlformats.org/presentationml/2006/main">
+  <p:cSld>
+    <p:spTree>
+      <p:nvGrpSpPr>
+        <p:cNvPr id="1" name=""/>
+        <p:cNvGrpSpPr/>
+        <p:nvPr/>
+      </p:nvGrpSpPr>
+      <p:grpSpPr>
+        <a:xfrm>
+          <a:off x="0" y="0"/>
+          <a:ext cx="0" cy="0"/>
+          <a:chOff x="0" y="0"/>
+          <a:chExt cx="0" cy="0"/>
+        </a:xfrm>
+      </p:grpSpPr>
       <p:sp>
         <p:nvSpPr>
           <p:cNvPr id="103" name="Rectangle 102"/>
@@ -19424,7 +19936,7 @@
 </p:sld>
 </file>
 
-<file path=ppt/slides/slide41.xml><?xml version="1.0" encoding="utf-8"?>
+<file path=ppt/slides/slide44.xml><?xml version="1.0" encoding="utf-8"?>
 <p:sld xmlns:a="http://schemas.openxmlformats.org/drawingml/2006/main" xmlns:r="http://schemas.openxmlformats.org/officeDocument/2006/relationships" xmlns:p="http://schemas.openxmlformats.org/presentationml/2006/main">
   <p:cSld>
     <p:spTree>
@@ -19587,7 +20099,7 @@
 </p:sld>
 </file>
 
-<file path=ppt/slides/slide42.xml><?xml version="1.0" encoding="utf-8"?>
+<file path=ppt/slides/slide45.xml><?xml version="1.0" encoding="utf-8"?>
 <p:sld xmlns:a="http://schemas.openxmlformats.org/drawingml/2006/main" xmlns:r="http://schemas.openxmlformats.org/officeDocument/2006/relationships" xmlns:p="http://schemas.openxmlformats.org/presentationml/2006/main">
   <p:cSld>
     <p:spTree>
@@ -19732,7 +20244,7 @@
               <a:pPr>
                 <a:defRPr/>
               </a:pPr>
-              <a:t>42</a:t>
+              <a:t>45</a:t>
             </a:fld>
             <a:endParaRPr lang="en-US"/>
           </a:p>
@@ -19751,7 +20263,7 @@
 </p:sld>
 </file>
 
-<file path=ppt/slides/slide43.xml><?xml version="1.0" encoding="utf-8"?>
+<file path=ppt/slides/slide46.xml><?xml version="1.0" encoding="utf-8"?>
 <p:sld xmlns:a="http://schemas.openxmlformats.org/drawingml/2006/main" xmlns:r="http://schemas.openxmlformats.org/officeDocument/2006/relationships" xmlns:p="http://schemas.openxmlformats.org/presentationml/2006/main">
   <p:cSld>
     <p:spTree>
@@ -20567,7 +21079,7 @@
 </p:sld>
 </file>
 
-<file path=ppt/slides/slide44.xml><?xml version="1.0" encoding="utf-8"?>
+<file path=ppt/slides/slide47.xml><?xml version="1.0" encoding="utf-8"?>
 <p:sld xmlns:a="http://schemas.openxmlformats.org/drawingml/2006/main" xmlns:r="http://schemas.openxmlformats.org/officeDocument/2006/relationships" xmlns:p="http://schemas.openxmlformats.org/presentationml/2006/main">
   <p:cSld>
     <p:spTree>

</xml_diff>